<commit_message>
updates plots for BA 2026
</commit_message>
<xml_diff>
--- a/scripts/phd_final/08_data/figs/data_figs/Data_figs_preliminary/data_figs.pptx
+++ b/scripts/phd_final/08_data/figs/data_figs/Data_figs_preliminary/data_figs.pptx
@@ -2,24 +2,24 @@
 <file path=ppt/presentation.xml><?xml version="1.0" encoding="utf-8"?>
 <p:presentation xmlns:a="http://schemas.openxmlformats.org/drawingml/2006/main" xmlns:r="http://schemas.openxmlformats.org/officeDocument/2006/relationships" xmlns:p="http://schemas.openxmlformats.org/presentationml/2006/main" saveSubsetFonts="1" autoCompressPictures="0">
   <p:sldMasterIdLst>
-    <p:sldMasterId id="2147483648" r:id="rId1"/>
+    <p:sldMasterId id="2147483660" r:id="rId1"/>
   </p:sldMasterIdLst>
   <p:sldIdLst>
     <p:sldId id="256" r:id="rId2"/>
     <p:sldId id="257" r:id="rId3"/>
-    <p:sldId id="259" r:id="rId4"/>
-    <p:sldId id="260" r:id="rId5"/>
+    <p:sldId id="260" r:id="rId4"/>
+    <p:sldId id="259" r:id="rId5"/>
     <p:sldId id="261" r:id="rId6"/>
     <p:sldId id="262" r:id="rId7"/>
     <p:sldId id="263" r:id="rId8"/>
   </p:sldIdLst>
-  <p:sldSz cx="12192000" cy="6858000"/>
+  <p:sldSz cx="30476825" cy="15243175"/>
   <p:notesSz cx="6858000" cy="9144000"/>
   <p:defaultTextStyle>
     <a:defPPr>
       <a:defRPr lang="en-US"/>
     </a:defPPr>
-    <a:lvl1pPr marL="0" algn="l" defTabSz="914400" rtl="0" eaLnBrk="1" latinLnBrk="0" hangingPunct="1">
+    <a:lvl1pPr marL="0" algn="l" defTabSz="457200" rtl="0" eaLnBrk="1" latinLnBrk="0" hangingPunct="1">
       <a:defRPr sz="1800" kern="1200">
         <a:solidFill>
           <a:schemeClr val="tx1"/>
@@ -29,7 +29,7 @@
         <a:cs typeface="+mn-cs"/>
       </a:defRPr>
     </a:lvl1pPr>
-    <a:lvl2pPr marL="457200" algn="l" defTabSz="914400" rtl="0" eaLnBrk="1" latinLnBrk="0" hangingPunct="1">
+    <a:lvl2pPr marL="457200" algn="l" defTabSz="457200" rtl="0" eaLnBrk="1" latinLnBrk="0" hangingPunct="1">
       <a:defRPr sz="1800" kern="1200">
         <a:solidFill>
           <a:schemeClr val="tx1"/>
@@ -39,7 +39,7 @@
         <a:cs typeface="+mn-cs"/>
       </a:defRPr>
     </a:lvl2pPr>
-    <a:lvl3pPr marL="914400" algn="l" defTabSz="914400" rtl="0" eaLnBrk="1" latinLnBrk="0" hangingPunct="1">
+    <a:lvl3pPr marL="914400" algn="l" defTabSz="457200" rtl="0" eaLnBrk="1" latinLnBrk="0" hangingPunct="1">
       <a:defRPr sz="1800" kern="1200">
         <a:solidFill>
           <a:schemeClr val="tx1"/>
@@ -49,7 +49,7 @@
         <a:cs typeface="+mn-cs"/>
       </a:defRPr>
     </a:lvl3pPr>
-    <a:lvl4pPr marL="1371600" algn="l" defTabSz="914400" rtl="0" eaLnBrk="1" latinLnBrk="0" hangingPunct="1">
+    <a:lvl4pPr marL="1371600" algn="l" defTabSz="457200" rtl="0" eaLnBrk="1" latinLnBrk="0" hangingPunct="1">
       <a:defRPr sz="1800" kern="1200">
         <a:solidFill>
           <a:schemeClr val="tx1"/>
@@ -59,7 +59,7 @@
         <a:cs typeface="+mn-cs"/>
       </a:defRPr>
     </a:lvl4pPr>
-    <a:lvl5pPr marL="1828800" algn="l" defTabSz="914400" rtl="0" eaLnBrk="1" latinLnBrk="0" hangingPunct="1">
+    <a:lvl5pPr marL="1828800" algn="l" defTabSz="457200" rtl="0" eaLnBrk="1" latinLnBrk="0" hangingPunct="1">
       <a:defRPr sz="1800" kern="1200">
         <a:solidFill>
           <a:schemeClr val="tx1"/>
@@ -69,7 +69,7 @@
         <a:cs typeface="+mn-cs"/>
       </a:defRPr>
     </a:lvl5pPr>
-    <a:lvl6pPr marL="2286000" algn="l" defTabSz="914400" rtl="0" eaLnBrk="1" latinLnBrk="0" hangingPunct="1">
+    <a:lvl6pPr marL="2286000" algn="l" defTabSz="457200" rtl="0" eaLnBrk="1" latinLnBrk="0" hangingPunct="1">
       <a:defRPr sz="1800" kern="1200">
         <a:solidFill>
           <a:schemeClr val="tx1"/>
@@ -79,7 +79,7 @@
         <a:cs typeface="+mn-cs"/>
       </a:defRPr>
     </a:lvl6pPr>
-    <a:lvl7pPr marL="2743200" algn="l" defTabSz="914400" rtl="0" eaLnBrk="1" latinLnBrk="0" hangingPunct="1">
+    <a:lvl7pPr marL="2743200" algn="l" defTabSz="457200" rtl="0" eaLnBrk="1" latinLnBrk="0" hangingPunct="1">
       <a:defRPr sz="1800" kern="1200">
         <a:solidFill>
           <a:schemeClr val="tx1"/>
@@ -89,7 +89,7 @@
         <a:cs typeface="+mn-cs"/>
       </a:defRPr>
     </a:lvl7pPr>
-    <a:lvl8pPr marL="3200400" algn="l" defTabSz="914400" rtl="0" eaLnBrk="1" latinLnBrk="0" hangingPunct="1">
+    <a:lvl8pPr marL="3200400" algn="l" defTabSz="457200" rtl="0" eaLnBrk="1" latinLnBrk="0" hangingPunct="1">
       <a:defRPr sz="1800" kern="1200">
         <a:solidFill>
           <a:schemeClr val="tx1"/>
@@ -99,7 +99,7 @@
         <a:cs typeface="+mn-cs"/>
       </a:defRPr>
     </a:lvl8pPr>
-    <a:lvl9pPr marL="3657600" algn="l" defTabSz="914400" rtl="0" eaLnBrk="1" latinLnBrk="0" hangingPunct="1">
+    <a:lvl9pPr marL="3657600" algn="l" defTabSz="457200" rtl="0" eaLnBrk="1" latinLnBrk="0" hangingPunct="1">
       <a:defRPr sz="1800" kern="1200">
         <a:solidFill>
           <a:schemeClr val="tx1"/>
@@ -110,6 +110,11 @@
       </a:defRPr>
     </a:lvl9pPr>
   </p:defaultTextStyle>
+  <p:extLst>
+    <p:ext uri="{EFAFB233-063F-42B5-8137-9DF3F51BA10A}">
+      <p15:sldGuideLst xmlns:p15="http://schemas.microsoft.com/office/powerpoint/2012/main"/>
+    </p:ext>
+  </p:extLst>
 </p:presentation>
 </file>
 
@@ -132,13 +137,7 @@
       </p:grpSpPr>
       <p:sp>
         <p:nvSpPr>
-          <p:cNvPr id="2" name="Title 1">
-            <a:extLst>
-              <a:ext uri="{FF2B5EF4-FFF2-40B4-BE49-F238E27FC236}">
-                <a16:creationId xmlns:a16="http://schemas.microsoft.com/office/drawing/2014/main" id="{6918A318-5A4C-CDB4-4897-B46F634E4608}"/>
-              </a:ext>
-            </a:extLst>
-          </p:cNvPr>
+          <p:cNvPr id="2" name="Title 1"/>
           <p:cNvSpPr>
             <a:spLocks noGrp="1"/>
           </p:cNvSpPr>
@@ -148,15 +147,15 @@
         </p:nvSpPr>
         <p:spPr>
           <a:xfrm>
-            <a:off x="1524000" y="1122363"/>
-            <a:ext cx="9144000" cy="2387600"/>
+            <a:off x="3809603" y="2494660"/>
+            <a:ext cx="22857619" cy="5306883"/>
           </a:xfrm>
         </p:spPr>
         <p:txBody>
           <a:bodyPr anchor="b"/>
           <a:lstStyle>
             <a:lvl1pPr algn="ctr">
-              <a:defRPr sz="6000"/>
+              <a:defRPr sz="13336"/>
             </a:lvl1pPr>
           </a:lstStyle>
           <a:p>
@@ -164,18 +163,13 @@
               <a:rPr lang="en-US"/>
               <a:t>Click to edit Master title style</a:t>
             </a:r>
-          </a:p>
-        </p:txBody>
-      </p:sp>
-      <p:sp>
-        <p:nvSpPr>
-          <p:cNvPr id="3" name="Subtitle 2">
-            <a:extLst>
-              <a:ext uri="{FF2B5EF4-FFF2-40B4-BE49-F238E27FC236}">
-                <a16:creationId xmlns:a16="http://schemas.microsoft.com/office/drawing/2014/main" id="{100B66E4-B006-F23B-DC20-4AC664038E1E}"/>
-              </a:ext>
-            </a:extLst>
-          </p:cNvPr>
+            <a:endParaRPr lang="en-US" dirty="0"/>
+          </a:p>
+        </p:txBody>
+      </p:sp>
+      <p:sp>
+        <p:nvSpPr>
+          <p:cNvPr id="3" name="Subtitle 2"/>
           <p:cNvSpPr>
             <a:spLocks noGrp="1"/>
           </p:cNvSpPr>
@@ -185,8 +179,8 @@
         </p:nvSpPr>
         <p:spPr>
           <a:xfrm>
-            <a:off x="1524000" y="3602038"/>
-            <a:ext cx="9144000" cy="1655762"/>
+            <a:off x="3809603" y="8006196"/>
+            <a:ext cx="22857619" cy="3680238"/>
           </a:xfrm>
         </p:spPr>
         <p:txBody>
@@ -194,39 +188,39 @@
           <a:lstStyle>
             <a:lvl1pPr marL="0" indent="0" algn="ctr">
               <a:buNone/>
-              <a:defRPr sz="2400"/>
+              <a:defRPr sz="5334"/>
             </a:lvl1pPr>
-            <a:lvl2pPr marL="457200" indent="0" algn="ctr">
-              <a:buNone/>
-              <a:defRPr sz="2000"/>
+            <a:lvl2pPr marL="1016218" indent="0" algn="ctr">
+              <a:buNone/>
+              <a:defRPr sz="4445"/>
             </a:lvl2pPr>
-            <a:lvl3pPr marL="914400" indent="0" algn="ctr">
-              <a:buNone/>
-              <a:defRPr sz="1800"/>
+            <a:lvl3pPr marL="2032437" indent="0" algn="ctr">
+              <a:buNone/>
+              <a:defRPr sz="4001"/>
             </a:lvl3pPr>
-            <a:lvl4pPr marL="1371600" indent="0" algn="ctr">
-              <a:buNone/>
-              <a:defRPr sz="1600"/>
+            <a:lvl4pPr marL="3048655" indent="0" algn="ctr">
+              <a:buNone/>
+              <a:defRPr sz="3556"/>
             </a:lvl4pPr>
-            <a:lvl5pPr marL="1828800" indent="0" algn="ctr">
-              <a:buNone/>
-              <a:defRPr sz="1600"/>
+            <a:lvl5pPr marL="4064874" indent="0" algn="ctr">
+              <a:buNone/>
+              <a:defRPr sz="3556"/>
             </a:lvl5pPr>
-            <a:lvl6pPr marL="2286000" indent="0" algn="ctr">
-              <a:buNone/>
-              <a:defRPr sz="1600"/>
+            <a:lvl6pPr marL="5081092" indent="0" algn="ctr">
+              <a:buNone/>
+              <a:defRPr sz="3556"/>
             </a:lvl6pPr>
-            <a:lvl7pPr marL="2743200" indent="0" algn="ctr">
-              <a:buNone/>
-              <a:defRPr sz="1600"/>
+            <a:lvl7pPr marL="6097311" indent="0" algn="ctr">
+              <a:buNone/>
+              <a:defRPr sz="3556"/>
             </a:lvl7pPr>
-            <a:lvl8pPr marL="3200400" indent="0" algn="ctr">
-              <a:buNone/>
-              <a:defRPr sz="1600"/>
+            <a:lvl8pPr marL="7113529" indent="0" algn="ctr">
+              <a:buNone/>
+              <a:defRPr sz="3556"/>
             </a:lvl8pPr>
-            <a:lvl9pPr marL="3657600" indent="0" algn="ctr">
-              <a:buNone/>
-              <a:defRPr sz="1600"/>
+            <a:lvl9pPr marL="8129748" indent="0" algn="ctr">
+              <a:buNone/>
+              <a:defRPr sz="3556"/>
             </a:lvl9pPr>
           </a:lstStyle>
           <a:p>
@@ -234,18 +228,13 @@
               <a:rPr lang="en-US"/>
               <a:t>Click to edit Master subtitle style</a:t>
             </a:r>
-          </a:p>
-        </p:txBody>
-      </p:sp>
-      <p:sp>
-        <p:nvSpPr>
-          <p:cNvPr id="4" name="Date Placeholder 3">
-            <a:extLst>
-              <a:ext uri="{FF2B5EF4-FFF2-40B4-BE49-F238E27FC236}">
-                <a16:creationId xmlns:a16="http://schemas.microsoft.com/office/drawing/2014/main" id="{8529BE3F-B420-851E-3335-5DA7813ACF59}"/>
-              </a:ext>
-            </a:extLst>
-          </p:cNvPr>
+            <a:endParaRPr lang="en-US" dirty="0"/>
+          </a:p>
+        </p:txBody>
+      </p:sp>
+      <p:sp>
+        <p:nvSpPr>
+          <p:cNvPr id="4" name="Date Placeholder 3"/>
           <p:cNvSpPr>
             <a:spLocks noGrp="1"/>
           </p:cNvSpPr>
@@ -260,7 +249,7 @@
           <a:p>
             <a:fld id="{32EB2BEB-40F2-354C-A8DB-62B53C266708}" type="datetimeFigureOut">
               <a:rPr lang="en-US" smtClean="0"/>
-              <a:t>3/19/26</a:t>
+              <a:t>4/7/26</a:t>
             </a:fld>
             <a:endParaRPr lang="en-US"/>
           </a:p>
@@ -268,13 +257,7 @@
       </p:sp>
       <p:sp>
         <p:nvSpPr>
-          <p:cNvPr id="5" name="Footer Placeholder 4">
-            <a:extLst>
-              <a:ext uri="{FF2B5EF4-FFF2-40B4-BE49-F238E27FC236}">
-                <a16:creationId xmlns:a16="http://schemas.microsoft.com/office/drawing/2014/main" id="{1ADEA6A3-95E6-BEAE-883A-9618C89C8FA6}"/>
-              </a:ext>
-            </a:extLst>
-          </p:cNvPr>
+          <p:cNvPr id="5" name="Footer Placeholder 4"/>
           <p:cNvSpPr>
             <a:spLocks noGrp="1"/>
           </p:cNvSpPr>
@@ -293,13 +276,7 @@
       </p:sp>
       <p:sp>
         <p:nvSpPr>
-          <p:cNvPr id="6" name="Slide Number Placeholder 5">
-            <a:extLst>
-              <a:ext uri="{FF2B5EF4-FFF2-40B4-BE49-F238E27FC236}">
-                <a16:creationId xmlns:a16="http://schemas.microsoft.com/office/drawing/2014/main" id="{CFAA54A8-3F93-898A-623E-C8952E837AD9}"/>
-              </a:ext>
-            </a:extLst>
-          </p:cNvPr>
+          <p:cNvPr id="6" name="Slide Number Placeholder 5"/>
           <p:cNvSpPr>
             <a:spLocks noGrp="1"/>
           </p:cNvSpPr>
@@ -323,7 +300,7 @@
     </p:spTree>
     <p:extLst>
       <p:ext uri="{BB962C8B-B14F-4D97-AF65-F5344CB8AC3E}">
-        <p14:creationId xmlns:p14="http://schemas.microsoft.com/office/powerpoint/2010/main" val="2388367141"/>
+        <p14:creationId xmlns:p14="http://schemas.microsoft.com/office/powerpoint/2010/main" val="107467178"/>
       </p:ext>
     </p:extLst>
   </p:cSld>
@@ -352,13 +329,7 @@
       </p:grpSpPr>
       <p:sp>
         <p:nvSpPr>
-          <p:cNvPr id="2" name="Title 1">
-            <a:extLst>
-              <a:ext uri="{FF2B5EF4-FFF2-40B4-BE49-F238E27FC236}">
-                <a16:creationId xmlns:a16="http://schemas.microsoft.com/office/drawing/2014/main" id="{DC22EEE3-2FB0-A5CC-5A47-A3AF881667AC}"/>
-              </a:ext>
-            </a:extLst>
-          </p:cNvPr>
+          <p:cNvPr id="2" name="Title 1"/>
           <p:cNvSpPr>
             <a:spLocks noGrp="1"/>
           </p:cNvSpPr>
@@ -375,18 +346,13 @@
               <a:rPr lang="en-US"/>
               <a:t>Click to edit Master title style</a:t>
             </a:r>
-          </a:p>
-        </p:txBody>
-      </p:sp>
-      <p:sp>
-        <p:nvSpPr>
-          <p:cNvPr id="3" name="Vertical Text Placeholder 2">
-            <a:extLst>
-              <a:ext uri="{FF2B5EF4-FFF2-40B4-BE49-F238E27FC236}">
-                <a16:creationId xmlns:a16="http://schemas.microsoft.com/office/drawing/2014/main" id="{57505C66-0F41-BEEB-08C8-D6EDD571E89D}"/>
-              </a:ext>
-            </a:extLst>
-          </p:cNvPr>
+            <a:endParaRPr lang="en-US" dirty="0"/>
+          </a:p>
+        </p:txBody>
+      </p:sp>
+      <p:sp>
+        <p:nvSpPr>
+          <p:cNvPr id="3" name="Vertical Text Placeholder 2"/>
           <p:cNvSpPr>
             <a:spLocks noGrp="1"/>
           </p:cNvSpPr>
@@ -432,18 +398,13 @@
               <a:rPr lang="en-US"/>
               <a:t>Fifth level</a:t>
             </a:r>
-          </a:p>
-        </p:txBody>
-      </p:sp>
-      <p:sp>
-        <p:nvSpPr>
-          <p:cNvPr id="4" name="Date Placeholder 3">
-            <a:extLst>
-              <a:ext uri="{FF2B5EF4-FFF2-40B4-BE49-F238E27FC236}">
-                <a16:creationId xmlns:a16="http://schemas.microsoft.com/office/drawing/2014/main" id="{82B0084F-9EDC-5BDE-9AD7-F53630FD1A5B}"/>
-              </a:ext>
-            </a:extLst>
-          </p:cNvPr>
+            <a:endParaRPr lang="en-US" dirty="0"/>
+          </a:p>
+        </p:txBody>
+      </p:sp>
+      <p:sp>
+        <p:nvSpPr>
+          <p:cNvPr id="4" name="Date Placeholder 3"/>
           <p:cNvSpPr>
             <a:spLocks noGrp="1"/>
           </p:cNvSpPr>
@@ -458,7 +419,7 @@
           <a:p>
             <a:fld id="{32EB2BEB-40F2-354C-A8DB-62B53C266708}" type="datetimeFigureOut">
               <a:rPr lang="en-US" smtClean="0"/>
-              <a:t>3/19/26</a:t>
+              <a:t>4/7/26</a:t>
             </a:fld>
             <a:endParaRPr lang="en-US"/>
           </a:p>
@@ -466,13 +427,7 @@
       </p:sp>
       <p:sp>
         <p:nvSpPr>
-          <p:cNvPr id="5" name="Footer Placeholder 4">
-            <a:extLst>
-              <a:ext uri="{FF2B5EF4-FFF2-40B4-BE49-F238E27FC236}">
-                <a16:creationId xmlns:a16="http://schemas.microsoft.com/office/drawing/2014/main" id="{DE93177F-8C1B-F30A-8397-D789BBB8CED1}"/>
-              </a:ext>
-            </a:extLst>
-          </p:cNvPr>
+          <p:cNvPr id="5" name="Footer Placeholder 4"/>
           <p:cNvSpPr>
             <a:spLocks noGrp="1"/>
           </p:cNvSpPr>
@@ -491,13 +446,7 @@
       </p:sp>
       <p:sp>
         <p:nvSpPr>
-          <p:cNvPr id="6" name="Slide Number Placeholder 5">
-            <a:extLst>
-              <a:ext uri="{FF2B5EF4-FFF2-40B4-BE49-F238E27FC236}">
-                <a16:creationId xmlns:a16="http://schemas.microsoft.com/office/drawing/2014/main" id="{4DDECA10-9970-5111-D080-239882075089}"/>
-              </a:ext>
-            </a:extLst>
-          </p:cNvPr>
+          <p:cNvPr id="6" name="Slide Number Placeholder 5"/>
           <p:cNvSpPr>
             <a:spLocks noGrp="1"/>
           </p:cNvSpPr>
@@ -521,7 +470,7 @@
     </p:spTree>
     <p:extLst>
       <p:ext uri="{BB962C8B-B14F-4D97-AF65-F5344CB8AC3E}">
-        <p14:creationId xmlns:p14="http://schemas.microsoft.com/office/powerpoint/2010/main" val="3075926377"/>
+        <p14:creationId xmlns:p14="http://schemas.microsoft.com/office/powerpoint/2010/main" val="4292960016"/>
       </p:ext>
     </p:extLst>
   </p:cSld>
@@ -550,13 +499,7 @@
       </p:grpSpPr>
       <p:sp>
         <p:nvSpPr>
-          <p:cNvPr id="2" name="Vertical Title 1">
-            <a:extLst>
-              <a:ext uri="{FF2B5EF4-FFF2-40B4-BE49-F238E27FC236}">
-                <a16:creationId xmlns:a16="http://schemas.microsoft.com/office/drawing/2014/main" id="{C6EA33CF-06B0-2540-4954-CC60BC3804EB}"/>
-              </a:ext>
-            </a:extLst>
-          </p:cNvPr>
+          <p:cNvPr id="2" name="Vertical Title 1"/>
           <p:cNvSpPr>
             <a:spLocks noGrp="1"/>
           </p:cNvSpPr>
@@ -566,8 +509,8 @@
         </p:nvSpPr>
         <p:spPr>
           <a:xfrm>
-            <a:off x="8724900" y="365125"/>
-            <a:ext cx="2628900" cy="5811838"/>
+            <a:off x="21809978" y="811558"/>
+            <a:ext cx="6571565" cy="12917886"/>
           </a:xfrm>
         </p:spPr>
         <p:txBody>
@@ -578,18 +521,13 @@
               <a:rPr lang="en-US"/>
               <a:t>Click to edit Master title style</a:t>
             </a:r>
-          </a:p>
-        </p:txBody>
-      </p:sp>
-      <p:sp>
-        <p:nvSpPr>
-          <p:cNvPr id="3" name="Vertical Text Placeholder 2">
-            <a:extLst>
-              <a:ext uri="{FF2B5EF4-FFF2-40B4-BE49-F238E27FC236}">
-                <a16:creationId xmlns:a16="http://schemas.microsoft.com/office/drawing/2014/main" id="{CFC155CE-6C26-C057-65AC-116547800CD3}"/>
-              </a:ext>
-            </a:extLst>
-          </p:cNvPr>
+            <a:endParaRPr lang="en-US" dirty="0"/>
+          </a:p>
+        </p:txBody>
+      </p:sp>
+      <p:sp>
+        <p:nvSpPr>
+          <p:cNvPr id="3" name="Vertical Text Placeholder 2"/>
           <p:cNvSpPr>
             <a:spLocks noGrp="1"/>
           </p:cNvSpPr>
@@ -599,8 +537,8 @@
         </p:nvSpPr>
         <p:spPr>
           <a:xfrm>
-            <a:off x="838200" y="365125"/>
-            <a:ext cx="7734300" cy="5811838"/>
+            <a:off x="2095282" y="811558"/>
+            <a:ext cx="19333736" cy="12917886"/>
           </a:xfrm>
         </p:spPr>
         <p:txBody>
@@ -640,18 +578,13 @@
               <a:rPr lang="en-US"/>
               <a:t>Fifth level</a:t>
             </a:r>
-          </a:p>
-        </p:txBody>
-      </p:sp>
-      <p:sp>
-        <p:nvSpPr>
-          <p:cNvPr id="4" name="Date Placeholder 3">
-            <a:extLst>
-              <a:ext uri="{FF2B5EF4-FFF2-40B4-BE49-F238E27FC236}">
-                <a16:creationId xmlns:a16="http://schemas.microsoft.com/office/drawing/2014/main" id="{61453BE9-01B2-5787-500F-0438FE53019B}"/>
-              </a:ext>
-            </a:extLst>
-          </p:cNvPr>
+            <a:endParaRPr lang="en-US" dirty="0"/>
+          </a:p>
+        </p:txBody>
+      </p:sp>
+      <p:sp>
+        <p:nvSpPr>
+          <p:cNvPr id="4" name="Date Placeholder 3"/>
           <p:cNvSpPr>
             <a:spLocks noGrp="1"/>
           </p:cNvSpPr>
@@ -666,7 +599,7 @@
           <a:p>
             <a:fld id="{32EB2BEB-40F2-354C-A8DB-62B53C266708}" type="datetimeFigureOut">
               <a:rPr lang="en-US" smtClean="0"/>
-              <a:t>3/19/26</a:t>
+              <a:t>4/7/26</a:t>
             </a:fld>
             <a:endParaRPr lang="en-US"/>
           </a:p>
@@ -674,13 +607,7 @@
       </p:sp>
       <p:sp>
         <p:nvSpPr>
-          <p:cNvPr id="5" name="Footer Placeholder 4">
-            <a:extLst>
-              <a:ext uri="{FF2B5EF4-FFF2-40B4-BE49-F238E27FC236}">
-                <a16:creationId xmlns:a16="http://schemas.microsoft.com/office/drawing/2014/main" id="{EB7B51BF-D457-BEFC-A77A-3B730C3FA2A0}"/>
-              </a:ext>
-            </a:extLst>
-          </p:cNvPr>
+          <p:cNvPr id="5" name="Footer Placeholder 4"/>
           <p:cNvSpPr>
             <a:spLocks noGrp="1"/>
           </p:cNvSpPr>
@@ -699,13 +626,7 @@
       </p:sp>
       <p:sp>
         <p:nvSpPr>
-          <p:cNvPr id="6" name="Slide Number Placeholder 5">
-            <a:extLst>
-              <a:ext uri="{FF2B5EF4-FFF2-40B4-BE49-F238E27FC236}">
-                <a16:creationId xmlns:a16="http://schemas.microsoft.com/office/drawing/2014/main" id="{8C6063F1-FF22-7989-C666-8A8F34416D75}"/>
-              </a:ext>
-            </a:extLst>
-          </p:cNvPr>
+          <p:cNvPr id="6" name="Slide Number Placeholder 5"/>
           <p:cNvSpPr>
             <a:spLocks noGrp="1"/>
           </p:cNvSpPr>
@@ -729,7 +650,7 @@
     </p:spTree>
     <p:extLst>
       <p:ext uri="{BB962C8B-B14F-4D97-AF65-F5344CB8AC3E}">
-        <p14:creationId xmlns:p14="http://schemas.microsoft.com/office/powerpoint/2010/main" val="81448693"/>
+        <p14:creationId xmlns:p14="http://schemas.microsoft.com/office/powerpoint/2010/main" val="291030294"/>
       </p:ext>
     </p:extLst>
   </p:cSld>
@@ -758,13 +679,7 @@
       </p:grpSpPr>
       <p:sp>
         <p:nvSpPr>
-          <p:cNvPr id="2" name="Title 1">
-            <a:extLst>
-              <a:ext uri="{FF2B5EF4-FFF2-40B4-BE49-F238E27FC236}">
-                <a16:creationId xmlns:a16="http://schemas.microsoft.com/office/drawing/2014/main" id="{10691281-C794-3516-4C80-5E53B1E27BC3}"/>
-              </a:ext>
-            </a:extLst>
-          </p:cNvPr>
+          <p:cNvPr id="2" name="Title 1"/>
           <p:cNvSpPr>
             <a:spLocks noGrp="1"/>
           </p:cNvSpPr>
@@ -781,18 +696,13 @@
               <a:rPr lang="en-US"/>
               <a:t>Click to edit Master title style</a:t>
             </a:r>
-          </a:p>
-        </p:txBody>
-      </p:sp>
-      <p:sp>
-        <p:nvSpPr>
-          <p:cNvPr id="3" name="Content Placeholder 2">
-            <a:extLst>
-              <a:ext uri="{FF2B5EF4-FFF2-40B4-BE49-F238E27FC236}">
-                <a16:creationId xmlns:a16="http://schemas.microsoft.com/office/drawing/2014/main" id="{1DC2E31F-82A9-0CD7-D030-87B4A3CF78D4}"/>
-              </a:ext>
-            </a:extLst>
-          </p:cNvPr>
+            <a:endParaRPr lang="en-US" dirty="0"/>
+          </a:p>
+        </p:txBody>
+      </p:sp>
+      <p:sp>
+        <p:nvSpPr>
+          <p:cNvPr id="3" name="Content Placeholder 2"/>
           <p:cNvSpPr>
             <a:spLocks noGrp="1"/>
           </p:cNvSpPr>
@@ -838,18 +748,13 @@
               <a:rPr lang="en-US"/>
               <a:t>Fifth level</a:t>
             </a:r>
-          </a:p>
-        </p:txBody>
-      </p:sp>
-      <p:sp>
-        <p:nvSpPr>
-          <p:cNvPr id="4" name="Date Placeholder 3">
-            <a:extLst>
-              <a:ext uri="{FF2B5EF4-FFF2-40B4-BE49-F238E27FC236}">
-                <a16:creationId xmlns:a16="http://schemas.microsoft.com/office/drawing/2014/main" id="{C1ABFDB1-E0A6-0B8A-CA0B-EB0457945291}"/>
-              </a:ext>
-            </a:extLst>
-          </p:cNvPr>
+            <a:endParaRPr lang="en-US" dirty="0"/>
+          </a:p>
+        </p:txBody>
+      </p:sp>
+      <p:sp>
+        <p:nvSpPr>
+          <p:cNvPr id="4" name="Date Placeholder 3"/>
           <p:cNvSpPr>
             <a:spLocks noGrp="1"/>
           </p:cNvSpPr>
@@ -864,7 +769,7 @@
           <a:p>
             <a:fld id="{32EB2BEB-40F2-354C-A8DB-62B53C266708}" type="datetimeFigureOut">
               <a:rPr lang="en-US" smtClean="0"/>
-              <a:t>3/19/26</a:t>
+              <a:t>4/7/26</a:t>
             </a:fld>
             <a:endParaRPr lang="en-US"/>
           </a:p>
@@ -872,13 +777,7 @@
       </p:sp>
       <p:sp>
         <p:nvSpPr>
-          <p:cNvPr id="5" name="Footer Placeholder 4">
-            <a:extLst>
-              <a:ext uri="{FF2B5EF4-FFF2-40B4-BE49-F238E27FC236}">
-                <a16:creationId xmlns:a16="http://schemas.microsoft.com/office/drawing/2014/main" id="{C86A2A64-4764-9665-10C3-6716817525BD}"/>
-              </a:ext>
-            </a:extLst>
-          </p:cNvPr>
+          <p:cNvPr id="5" name="Footer Placeholder 4"/>
           <p:cNvSpPr>
             <a:spLocks noGrp="1"/>
           </p:cNvSpPr>
@@ -897,13 +796,7 @@
       </p:sp>
       <p:sp>
         <p:nvSpPr>
-          <p:cNvPr id="6" name="Slide Number Placeholder 5">
-            <a:extLst>
-              <a:ext uri="{FF2B5EF4-FFF2-40B4-BE49-F238E27FC236}">
-                <a16:creationId xmlns:a16="http://schemas.microsoft.com/office/drawing/2014/main" id="{96DBB9BF-6BEE-F25C-3977-BCB2F38F4DE3}"/>
-              </a:ext>
-            </a:extLst>
-          </p:cNvPr>
+          <p:cNvPr id="6" name="Slide Number Placeholder 5"/>
           <p:cNvSpPr>
             <a:spLocks noGrp="1"/>
           </p:cNvSpPr>
@@ -927,7 +820,7 @@
     </p:spTree>
     <p:extLst>
       <p:ext uri="{BB962C8B-B14F-4D97-AF65-F5344CB8AC3E}">
-        <p14:creationId xmlns:p14="http://schemas.microsoft.com/office/powerpoint/2010/main" val="3248506023"/>
+        <p14:creationId xmlns:p14="http://schemas.microsoft.com/office/powerpoint/2010/main" val="1769098030"/>
       </p:ext>
     </p:extLst>
   </p:cSld>
@@ -956,13 +849,7 @@
       </p:grpSpPr>
       <p:sp>
         <p:nvSpPr>
-          <p:cNvPr id="2" name="Title 1">
-            <a:extLst>
-              <a:ext uri="{FF2B5EF4-FFF2-40B4-BE49-F238E27FC236}">
-                <a16:creationId xmlns:a16="http://schemas.microsoft.com/office/drawing/2014/main" id="{9F165264-653B-5F61-A420-3EBAFA983B02}"/>
-              </a:ext>
-            </a:extLst>
-          </p:cNvPr>
+          <p:cNvPr id="2" name="Title 1"/>
           <p:cNvSpPr>
             <a:spLocks noGrp="1"/>
           </p:cNvSpPr>
@@ -972,15 +859,15 @@
         </p:nvSpPr>
         <p:spPr>
           <a:xfrm>
-            <a:off x="831850" y="1709738"/>
-            <a:ext cx="10515600" cy="2852737"/>
+            <a:off x="2079408" y="3800211"/>
+            <a:ext cx="26286262" cy="6340736"/>
           </a:xfrm>
         </p:spPr>
         <p:txBody>
           <a:bodyPr anchor="b"/>
           <a:lstStyle>
             <a:lvl1pPr>
-              <a:defRPr sz="6000"/>
+              <a:defRPr sz="13336"/>
             </a:lvl1pPr>
           </a:lstStyle>
           <a:p>
@@ -988,18 +875,13 @@
               <a:rPr lang="en-US"/>
               <a:t>Click to edit Master title style</a:t>
             </a:r>
-          </a:p>
-        </p:txBody>
-      </p:sp>
-      <p:sp>
-        <p:nvSpPr>
-          <p:cNvPr id="3" name="Text Placeholder 2">
-            <a:extLst>
-              <a:ext uri="{FF2B5EF4-FFF2-40B4-BE49-F238E27FC236}">
-                <a16:creationId xmlns:a16="http://schemas.microsoft.com/office/drawing/2014/main" id="{318912C0-657D-6CDE-7DD1-E323A2F2BFA0}"/>
-              </a:ext>
-            </a:extLst>
-          </p:cNvPr>
+            <a:endParaRPr lang="en-US" dirty="0"/>
+          </a:p>
+        </p:txBody>
+      </p:sp>
+      <p:sp>
+        <p:nvSpPr>
+          <p:cNvPr id="3" name="Text Placeholder 2"/>
           <p:cNvSpPr>
             <a:spLocks noGrp="1"/>
           </p:cNvSpPr>
@@ -1009,8 +891,8 @@
         </p:nvSpPr>
         <p:spPr>
           <a:xfrm>
-            <a:off x="831850" y="4589463"/>
-            <a:ext cx="10515600" cy="1500187"/>
+            <a:off x="2079408" y="10200933"/>
+            <a:ext cx="26286262" cy="3334443"/>
           </a:xfrm>
         </p:spPr>
         <p:txBody>
@@ -1018,7 +900,7 @@
           <a:lstStyle>
             <a:lvl1pPr marL="0" indent="0">
               <a:buNone/>
-              <a:defRPr sz="2400">
+              <a:defRPr sz="5334">
                 <a:solidFill>
                   <a:schemeClr val="tx1">
                     <a:tint val="82000"/>
@@ -1026,9 +908,9 @@
                 </a:solidFill>
               </a:defRPr>
             </a:lvl1pPr>
-            <a:lvl2pPr marL="457200" indent="0">
-              <a:buNone/>
-              <a:defRPr sz="2000">
+            <a:lvl2pPr marL="1016218" indent="0">
+              <a:buNone/>
+              <a:defRPr sz="4445">
                 <a:solidFill>
                   <a:schemeClr val="tx1">
                     <a:tint val="82000"/>
@@ -1036,9 +918,9 @@
                 </a:solidFill>
               </a:defRPr>
             </a:lvl2pPr>
-            <a:lvl3pPr marL="914400" indent="0">
-              <a:buNone/>
-              <a:defRPr sz="1800">
+            <a:lvl3pPr marL="2032437" indent="0">
+              <a:buNone/>
+              <a:defRPr sz="4001">
                 <a:solidFill>
                   <a:schemeClr val="tx1">
                     <a:tint val="82000"/>
@@ -1046,9 +928,9 @@
                 </a:solidFill>
               </a:defRPr>
             </a:lvl3pPr>
-            <a:lvl4pPr marL="1371600" indent="0">
-              <a:buNone/>
-              <a:defRPr sz="1600">
+            <a:lvl4pPr marL="3048655" indent="0">
+              <a:buNone/>
+              <a:defRPr sz="3556">
                 <a:solidFill>
                   <a:schemeClr val="tx1">
                     <a:tint val="82000"/>
@@ -1056,9 +938,9 @@
                 </a:solidFill>
               </a:defRPr>
             </a:lvl4pPr>
-            <a:lvl5pPr marL="1828800" indent="0">
-              <a:buNone/>
-              <a:defRPr sz="1600">
+            <a:lvl5pPr marL="4064874" indent="0">
+              <a:buNone/>
+              <a:defRPr sz="3556">
                 <a:solidFill>
                   <a:schemeClr val="tx1">
                     <a:tint val="82000"/>
@@ -1066,9 +948,9 @@
                 </a:solidFill>
               </a:defRPr>
             </a:lvl5pPr>
-            <a:lvl6pPr marL="2286000" indent="0">
-              <a:buNone/>
-              <a:defRPr sz="1600">
+            <a:lvl6pPr marL="5081092" indent="0">
+              <a:buNone/>
+              <a:defRPr sz="3556">
                 <a:solidFill>
                   <a:schemeClr val="tx1">
                     <a:tint val="82000"/>
@@ -1076,9 +958,9 @@
                 </a:solidFill>
               </a:defRPr>
             </a:lvl6pPr>
-            <a:lvl7pPr marL="2743200" indent="0">
-              <a:buNone/>
-              <a:defRPr sz="1600">
+            <a:lvl7pPr marL="6097311" indent="0">
+              <a:buNone/>
+              <a:defRPr sz="3556">
                 <a:solidFill>
                   <a:schemeClr val="tx1">
                     <a:tint val="82000"/>
@@ -1086,9 +968,9 @@
                 </a:solidFill>
               </a:defRPr>
             </a:lvl7pPr>
-            <a:lvl8pPr marL="3200400" indent="0">
-              <a:buNone/>
-              <a:defRPr sz="1600">
+            <a:lvl8pPr marL="7113529" indent="0">
+              <a:buNone/>
+              <a:defRPr sz="3556">
                 <a:solidFill>
                   <a:schemeClr val="tx1">
                     <a:tint val="82000"/>
@@ -1096,9 +978,9 @@
                 </a:solidFill>
               </a:defRPr>
             </a:lvl8pPr>
-            <a:lvl9pPr marL="3657600" indent="0">
-              <a:buNone/>
-              <a:defRPr sz="1600">
+            <a:lvl9pPr marL="8129748" indent="0">
+              <a:buNone/>
+              <a:defRPr sz="3556">
                 <a:solidFill>
                   <a:schemeClr val="tx1">
                     <a:tint val="82000"/>
@@ -1118,13 +1000,7 @@
       </p:sp>
       <p:sp>
         <p:nvSpPr>
-          <p:cNvPr id="4" name="Date Placeholder 3">
-            <a:extLst>
-              <a:ext uri="{FF2B5EF4-FFF2-40B4-BE49-F238E27FC236}">
-                <a16:creationId xmlns:a16="http://schemas.microsoft.com/office/drawing/2014/main" id="{060E6BB2-967D-6D0F-5D6B-3CF5AAF98A9E}"/>
-              </a:ext>
-            </a:extLst>
-          </p:cNvPr>
+          <p:cNvPr id="4" name="Date Placeholder 3"/>
           <p:cNvSpPr>
             <a:spLocks noGrp="1"/>
           </p:cNvSpPr>
@@ -1139,7 +1015,7 @@
           <a:p>
             <a:fld id="{32EB2BEB-40F2-354C-A8DB-62B53C266708}" type="datetimeFigureOut">
               <a:rPr lang="en-US" smtClean="0"/>
-              <a:t>3/19/26</a:t>
+              <a:t>4/7/26</a:t>
             </a:fld>
             <a:endParaRPr lang="en-US"/>
           </a:p>
@@ -1147,13 +1023,7 @@
       </p:sp>
       <p:sp>
         <p:nvSpPr>
-          <p:cNvPr id="5" name="Footer Placeholder 4">
-            <a:extLst>
-              <a:ext uri="{FF2B5EF4-FFF2-40B4-BE49-F238E27FC236}">
-                <a16:creationId xmlns:a16="http://schemas.microsoft.com/office/drawing/2014/main" id="{475DE104-01BD-E6B9-6CAB-D496934D3762}"/>
-              </a:ext>
-            </a:extLst>
-          </p:cNvPr>
+          <p:cNvPr id="5" name="Footer Placeholder 4"/>
           <p:cNvSpPr>
             <a:spLocks noGrp="1"/>
           </p:cNvSpPr>
@@ -1172,13 +1042,7 @@
       </p:sp>
       <p:sp>
         <p:nvSpPr>
-          <p:cNvPr id="6" name="Slide Number Placeholder 5">
-            <a:extLst>
-              <a:ext uri="{FF2B5EF4-FFF2-40B4-BE49-F238E27FC236}">
-                <a16:creationId xmlns:a16="http://schemas.microsoft.com/office/drawing/2014/main" id="{D205AB4A-8AAE-199F-F4DB-EE720911B007}"/>
-              </a:ext>
-            </a:extLst>
-          </p:cNvPr>
+          <p:cNvPr id="6" name="Slide Number Placeholder 5"/>
           <p:cNvSpPr>
             <a:spLocks noGrp="1"/>
           </p:cNvSpPr>
@@ -1202,7 +1066,7 @@
     </p:spTree>
     <p:extLst>
       <p:ext uri="{BB962C8B-B14F-4D97-AF65-F5344CB8AC3E}">
-        <p14:creationId xmlns:p14="http://schemas.microsoft.com/office/powerpoint/2010/main" val="1987329911"/>
+        <p14:creationId xmlns:p14="http://schemas.microsoft.com/office/powerpoint/2010/main" val="227690677"/>
       </p:ext>
     </p:extLst>
   </p:cSld>
@@ -1231,13 +1095,7 @@
       </p:grpSpPr>
       <p:sp>
         <p:nvSpPr>
-          <p:cNvPr id="2" name="Title 1">
-            <a:extLst>
-              <a:ext uri="{FF2B5EF4-FFF2-40B4-BE49-F238E27FC236}">
-                <a16:creationId xmlns:a16="http://schemas.microsoft.com/office/drawing/2014/main" id="{B50DB0D5-9385-4492-8422-BA20D3B56280}"/>
-              </a:ext>
-            </a:extLst>
-          </p:cNvPr>
+          <p:cNvPr id="2" name="Title 1"/>
           <p:cNvSpPr>
             <a:spLocks noGrp="1"/>
           </p:cNvSpPr>
@@ -1254,18 +1112,13 @@
               <a:rPr lang="en-US"/>
               <a:t>Click to edit Master title style</a:t>
             </a:r>
-          </a:p>
-        </p:txBody>
-      </p:sp>
-      <p:sp>
-        <p:nvSpPr>
-          <p:cNvPr id="3" name="Content Placeholder 2">
-            <a:extLst>
-              <a:ext uri="{FF2B5EF4-FFF2-40B4-BE49-F238E27FC236}">
-                <a16:creationId xmlns:a16="http://schemas.microsoft.com/office/drawing/2014/main" id="{10F61B9B-7E83-57C8-BB21-D66A8A6805A0}"/>
-              </a:ext>
-            </a:extLst>
-          </p:cNvPr>
+            <a:endParaRPr lang="en-US" dirty="0"/>
+          </a:p>
+        </p:txBody>
+      </p:sp>
+      <p:sp>
+        <p:nvSpPr>
+          <p:cNvPr id="3" name="Content Placeholder 2"/>
           <p:cNvSpPr>
             <a:spLocks noGrp="1"/>
           </p:cNvSpPr>
@@ -1275,8 +1128,8 @@
         </p:nvSpPr>
         <p:spPr>
           <a:xfrm>
-            <a:off x="838200" y="1825625"/>
-            <a:ext cx="5181600" cy="4351338"/>
+            <a:off x="2095282" y="4057789"/>
+            <a:ext cx="12952651" cy="9671655"/>
           </a:xfrm>
         </p:spPr>
         <p:txBody>
@@ -1316,18 +1169,13 @@
               <a:rPr lang="en-US"/>
               <a:t>Fifth level</a:t>
             </a:r>
-          </a:p>
-        </p:txBody>
-      </p:sp>
-      <p:sp>
-        <p:nvSpPr>
-          <p:cNvPr id="4" name="Content Placeholder 3">
-            <a:extLst>
-              <a:ext uri="{FF2B5EF4-FFF2-40B4-BE49-F238E27FC236}">
-                <a16:creationId xmlns:a16="http://schemas.microsoft.com/office/drawing/2014/main" id="{79327423-D204-C24D-FEE6-56C8F55DD29A}"/>
-              </a:ext>
-            </a:extLst>
-          </p:cNvPr>
+            <a:endParaRPr lang="en-US" dirty="0"/>
+          </a:p>
+        </p:txBody>
+      </p:sp>
+      <p:sp>
+        <p:nvSpPr>
+          <p:cNvPr id="4" name="Content Placeholder 3"/>
           <p:cNvSpPr>
             <a:spLocks noGrp="1"/>
           </p:cNvSpPr>
@@ -1337,8 +1185,8 @@
         </p:nvSpPr>
         <p:spPr>
           <a:xfrm>
-            <a:off x="6172200" y="1825625"/>
-            <a:ext cx="5181600" cy="4351338"/>
+            <a:off x="15428892" y="4057789"/>
+            <a:ext cx="12952651" cy="9671655"/>
           </a:xfrm>
         </p:spPr>
         <p:txBody>
@@ -1378,18 +1226,13 @@
               <a:rPr lang="en-US"/>
               <a:t>Fifth level</a:t>
             </a:r>
-          </a:p>
-        </p:txBody>
-      </p:sp>
-      <p:sp>
-        <p:nvSpPr>
-          <p:cNvPr id="5" name="Date Placeholder 4">
-            <a:extLst>
-              <a:ext uri="{FF2B5EF4-FFF2-40B4-BE49-F238E27FC236}">
-                <a16:creationId xmlns:a16="http://schemas.microsoft.com/office/drawing/2014/main" id="{CF25CDD1-C4A5-837D-FF91-98B63B302668}"/>
-              </a:ext>
-            </a:extLst>
-          </p:cNvPr>
+            <a:endParaRPr lang="en-US" dirty="0"/>
+          </a:p>
+        </p:txBody>
+      </p:sp>
+      <p:sp>
+        <p:nvSpPr>
+          <p:cNvPr id="5" name="Date Placeholder 4"/>
           <p:cNvSpPr>
             <a:spLocks noGrp="1"/>
           </p:cNvSpPr>
@@ -1404,7 +1247,7 @@
           <a:p>
             <a:fld id="{32EB2BEB-40F2-354C-A8DB-62B53C266708}" type="datetimeFigureOut">
               <a:rPr lang="en-US" smtClean="0"/>
-              <a:t>3/19/26</a:t>
+              <a:t>4/7/26</a:t>
             </a:fld>
             <a:endParaRPr lang="en-US"/>
           </a:p>
@@ -1412,13 +1255,7 @@
       </p:sp>
       <p:sp>
         <p:nvSpPr>
-          <p:cNvPr id="6" name="Footer Placeholder 5">
-            <a:extLst>
-              <a:ext uri="{FF2B5EF4-FFF2-40B4-BE49-F238E27FC236}">
-                <a16:creationId xmlns:a16="http://schemas.microsoft.com/office/drawing/2014/main" id="{0B394941-B4B2-DCE7-1ACC-DA395A29F69D}"/>
-              </a:ext>
-            </a:extLst>
-          </p:cNvPr>
+          <p:cNvPr id="6" name="Footer Placeholder 5"/>
           <p:cNvSpPr>
             <a:spLocks noGrp="1"/>
           </p:cNvSpPr>
@@ -1437,13 +1274,7 @@
       </p:sp>
       <p:sp>
         <p:nvSpPr>
-          <p:cNvPr id="7" name="Slide Number Placeholder 6">
-            <a:extLst>
-              <a:ext uri="{FF2B5EF4-FFF2-40B4-BE49-F238E27FC236}">
-                <a16:creationId xmlns:a16="http://schemas.microsoft.com/office/drawing/2014/main" id="{FFF2C4C7-AE76-61F2-241A-7F74FE18F379}"/>
-              </a:ext>
-            </a:extLst>
-          </p:cNvPr>
+          <p:cNvPr id="7" name="Slide Number Placeholder 6"/>
           <p:cNvSpPr>
             <a:spLocks noGrp="1"/>
           </p:cNvSpPr>
@@ -1467,7 +1298,7 @@
     </p:spTree>
     <p:extLst>
       <p:ext uri="{BB962C8B-B14F-4D97-AF65-F5344CB8AC3E}">
-        <p14:creationId xmlns:p14="http://schemas.microsoft.com/office/powerpoint/2010/main" val="282101503"/>
+        <p14:creationId xmlns:p14="http://schemas.microsoft.com/office/powerpoint/2010/main" val="1804300748"/>
       </p:ext>
     </p:extLst>
   </p:cSld>
@@ -1496,13 +1327,7 @@
       </p:grpSpPr>
       <p:sp>
         <p:nvSpPr>
-          <p:cNvPr id="2" name="Title 1">
-            <a:extLst>
-              <a:ext uri="{FF2B5EF4-FFF2-40B4-BE49-F238E27FC236}">
-                <a16:creationId xmlns:a16="http://schemas.microsoft.com/office/drawing/2014/main" id="{E6C60A06-E9D2-11F1-B622-57CEBED594BD}"/>
-              </a:ext>
-            </a:extLst>
-          </p:cNvPr>
+          <p:cNvPr id="2" name="Title 1"/>
           <p:cNvSpPr>
             <a:spLocks noGrp="1"/>
           </p:cNvSpPr>
@@ -1512,8 +1337,8 @@
         </p:nvSpPr>
         <p:spPr>
           <a:xfrm>
-            <a:off x="839788" y="365125"/>
-            <a:ext cx="10515600" cy="1325563"/>
+            <a:off x="2099251" y="811559"/>
+            <a:ext cx="26286262" cy="2946309"/>
           </a:xfrm>
         </p:spPr>
         <p:txBody>
@@ -1524,18 +1349,13 @@
               <a:rPr lang="en-US"/>
               <a:t>Click to edit Master title style</a:t>
             </a:r>
-          </a:p>
-        </p:txBody>
-      </p:sp>
-      <p:sp>
-        <p:nvSpPr>
-          <p:cNvPr id="3" name="Text Placeholder 2">
-            <a:extLst>
-              <a:ext uri="{FF2B5EF4-FFF2-40B4-BE49-F238E27FC236}">
-                <a16:creationId xmlns:a16="http://schemas.microsoft.com/office/drawing/2014/main" id="{3EABBDCD-330A-7898-93F5-DCE10112467F}"/>
-              </a:ext>
-            </a:extLst>
-          </p:cNvPr>
+            <a:endParaRPr lang="en-US" dirty="0"/>
+          </a:p>
+        </p:txBody>
+      </p:sp>
+      <p:sp>
+        <p:nvSpPr>
+          <p:cNvPr id="3" name="Text Placeholder 2"/>
           <p:cNvSpPr>
             <a:spLocks noGrp="1"/>
           </p:cNvSpPr>
@@ -1545,8 +1365,8 @@
         </p:nvSpPr>
         <p:spPr>
           <a:xfrm>
-            <a:off x="839788" y="1681163"/>
-            <a:ext cx="5157787" cy="823912"/>
+            <a:off x="2099253" y="3736696"/>
+            <a:ext cx="12893124" cy="1831297"/>
           </a:xfrm>
         </p:spPr>
         <p:txBody>
@@ -1554,39 +1374,39 @@
           <a:lstStyle>
             <a:lvl1pPr marL="0" indent="0">
               <a:buNone/>
-              <a:defRPr sz="2400" b="1"/>
+              <a:defRPr sz="5334" b="1"/>
             </a:lvl1pPr>
-            <a:lvl2pPr marL="457200" indent="0">
-              <a:buNone/>
-              <a:defRPr sz="2000" b="1"/>
+            <a:lvl2pPr marL="1016218" indent="0">
+              <a:buNone/>
+              <a:defRPr sz="4445" b="1"/>
             </a:lvl2pPr>
-            <a:lvl3pPr marL="914400" indent="0">
-              <a:buNone/>
-              <a:defRPr sz="1800" b="1"/>
+            <a:lvl3pPr marL="2032437" indent="0">
+              <a:buNone/>
+              <a:defRPr sz="4001" b="1"/>
             </a:lvl3pPr>
-            <a:lvl4pPr marL="1371600" indent="0">
-              <a:buNone/>
-              <a:defRPr sz="1600" b="1"/>
+            <a:lvl4pPr marL="3048655" indent="0">
+              <a:buNone/>
+              <a:defRPr sz="3556" b="1"/>
             </a:lvl4pPr>
-            <a:lvl5pPr marL="1828800" indent="0">
-              <a:buNone/>
-              <a:defRPr sz="1600" b="1"/>
+            <a:lvl5pPr marL="4064874" indent="0">
+              <a:buNone/>
+              <a:defRPr sz="3556" b="1"/>
             </a:lvl5pPr>
-            <a:lvl6pPr marL="2286000" indent="0">
-              <a:buNone/>
-              <a:defRPr sz="1600" b="1"/>
+            <a:lvl6pPr marL="5081092" indent="0">
+              <a:buNone/>
+              <a:defRPr sz="3556" b="1"/>
             </a:lvl6pPr>
-            <a:lvl7pPr marL="2743200" indent="0">
-              <a:buNone/>
-              <a:defRPr sz="1600" b="1"/>
+            <a:lvl7pPr marL="6097311" indent="0">
+              <a:buNone/>
+              <a:defRPr sz="3556" b="1"/>
             </a:lvl7pPr>
-            <a:lvl8pPr marL="3200400" indent="0">
-              <a:buNone/>
-              <a:defRPr sz="1600" b="1"/>
+            <a:lvl8pPr marL="7113529" indent="0">
+              <a:buNone/>
+              <a:defRPr sz="3556" b="1"/>
             </a:lvl8pPr>
-            <a:lvl9pPr marL="3657600" indent="0">
-              <a:buNone/>
-              <a:defRPr sz="1600" b="1"/>
+            <a:lvl9pPr marL="8129748" indent="0">
+              <a:buNone/>
+              <a:defRPr sz="3556" b="1"/>
             </a:lvl9pPr>
           </a:lstStyle>
           <a:p>
@@ -1600,13 +1420,7 @@
       </p:sp>
       <p:sp>
         <p:nvSpPr>
-          <p:cNvPr id="4" name="Content Placeholder 3">
-            <a:extLst>
-              <a:ext uri="{FF2B5EF4-FFF2-40B4-BE49-F238E27FC236}">
-                <a16:creationId xmlns:a16="http://schemas.microsoft.com/office/drawing/2014/main" id="{A2F2D34E-0C58-F0E9-3017-09BE0B2410BA}"/>
-              </a:ext>
-            </a:extLst>
-          </p:cNvPr>
+          <p:cNvPr id="4" name="Content Placeholder 3"/>
           <p:cNvSpPr>
             <a:spLocks noGrp="1"/>
           </p:cNvSpPr>
@@ -1616,8 +1430,8 @@
         </p:nvSpPr>
         <p:spPr>
           <a:xfrm>
-            <a:off x="839788" y="2505075"/>
-            <a:ext cx="5157787" cy="3684588"/>
+            <a:off x="2099253" y="5567993"/>
+            <a:ext cx="12893124" cy="8189679"/>
           </a:xfrm>
         </p:spPr>
         <p:txBody>
@@ -1657,18 +1471,13 @@
               <a:rPr lang="en-US"/>
               <a:t>Fifth level</a:t>
             </a:r>
-          </a:p>
-        </p:txBody>
-      </p:sp>
-      <p:sp>
-        <p:nvSpPr>
-          <p:cNvPr id="5" name="Text Placeholder 4">
-            <a:extLst>
-              <a:ext uri="{FF2B5EF4-FFF2-40B4-BE49-F238E27FC236}">
-                <a16:creationId xmlns:a16="http://schemas.microsoft.com/office/drawing/2014/main" id="{D191E08C-4B2C-62B2-62AD-851ADC2FC8ED}"/>
-              </a:ext>
-            </a:extLst>
-          </p:cNvPr>
+            <a:endParaRPr lang="en-US" dirty="0"/>
+          </a:p>
+        </p:txBody>
+      </p:sp>
+      <p:sp>
+        <p:nvSpPr>
+          <p:cNvPr id="5" name="Text Placeholder 4"/>
           <p:cNvSpPr>
             <a:spLocks noGrp="1"/>
           </p:cNvSpPr>
@@ -1678,8 +1487,8 @@
         </p:nvSpPr>
         <p:spPr>
           <a:xfrm>
-            <a:off x="6172200" y="1681163"/>
-            <a:ext cx="5183188" cy="823912"/>
+            <a:off x="15428893" y="3736696"/>
+            <a:ext cx="12956620" cy="1831297"/>
           </a:xfrm>
         </p:spPr>
         <p:txBody>
@@ -1687,39 +1496,39 @@
           <a:lstStyle>
             <a:lvl1pPr marL="0" indent="0">
               <a:buNone/>
-              <a:defRPr sz="2400" b="1"/>
+              <a:defRPr sz="5334" b="1"/>
             </a:lvl1pPr>
-            <a:lvl2pPr marL="457200" indent="0">
-              <a:buNone/>
-              <a:defRPr sz="2000" b="1"/>
+            <a:lvl2pPr marL="1016218" indent="0">
+              <a:buNone/>
+              <a:defRPr sz="4445" b="1"/>
             </a:lvl2pPr>
-            <a:lvl3pPr marL="914400" indent="0">
-              <a:buNone/>
-              <a:defRPr sz="1800" b="1"/>
+            <a:lvl3pPr marL="2032437" indent="0">
+              <a:buNone/>
+              <a:defRPr sz="4001" b="1"/>
             </a:lvl3pPr>
-            <a:lvl4pPr marL="1371600" indent="0">
-              <a:buNone/>
-              <a:defRPr sz="1600" b="1"/>
+            <a:lvl4pPr marL="3048655" indent="0">
+              <a:buNone/>
+              <a:defRPr sz="3556" b="1"/>
             </a:lvl4pPr>
-            <a:lvl5pPr marL="1828800" indent="0">
-              <a:buNone/>
-              <a:defRPr sz="1600" b="1"/>
+            <a:lvl5pPr marL="4064874" indent="0">
+              <a:buNone/>
+              <a:defRPr sz="3556" b="1"/>
             </a:lvl5pPr>
-            <a:lvl6pPr marL="2286000" indent="0">
-              <a:buNone/>
-              <a:defRPr sz="1600" b="1"/>
+            <a:lvl6pPr marL="5081092" indent="0">
+              <a:buNone/>
+              <a:defRPr sz="3556" b="1"/>
             </a:lvl6pPr>
-            <a:lvl7pPr marL="2743200" indent="0">
-              <a:buNone/>
-              <a:defRPr sz="1600" b="1"/>
+            <a:lvl7pPr marL="6097311" indent="0">
+              <a:buNone/>
+              <a:defRPr sz="3556" b="1"/>
             </a:lvl7pPr>
-            <a:lvl8pPr marL="3200400" indent="0">
-              <a:buNone/>
-              <a:defRPr sz="1600" b="1"/>
+            <a:lvl8pPr marL="7113529" indent="0">
+              <a:buNone/>
+              <a:defRPr sz="3556" b="1"/>
             </a:lvl8pPr>
-            <a:lvl9pPr marL="3657600" indent="0">
-              <a:buNone/>
-              <a:defRPr sz="1600" b="1"/>
+            <a:lvl9pPr marL="8129748" indent="0">
+              <a:buNone/>
+              <a:defRPr sz="3556" b="1"/>
             </a:lvl9pPr>
           </a:lstStyle>
           <a:p>
@@ -1733,13 +1542,7 @@
       </p:sp>
       <p:sp>
         <p:nvSpPr>
-          <p:cNvPr id="6" name="Content Placeholder 5">
-            <a:extLst>
-              <a:ext uri="{FF2B5EF4-FFF2-40B4-BE49-F238E27FC236}">
-                <a16:creationId xmlns:a16="http://schemas.microsoft.com/office/drawing/2014/main" id="{A4ECA82E-8209-CC70-2A9F-80A354A67391}"/>
-              </a:ext>
-            </a:extLst>
-          </p:cNvPr>
+          <p:cNvPr id="6" name="Content Placeholder 5"/>
           <p:cNvSpPr>
             <a:spLocks noGrp="1"/>
           </p:cNvSpPr>
@@ -1749,8 +1552,8 @@
         </p:nvSpPr>
         <p:spPr>
           <a:xfrm>
-            <a:off x="6172200" y="2505075"/>
-            <a:ext cx="5183188" cy="3684588"/>
+            <a:off x="15428893" y="5567993"/>
+            <a:ext cx="12956620" cy="8189679"/>
           </a:xfrm>
         </p:spPr>
         <p:txBody>
@@ -1790,18 +1593,13 @@
               <a:rPr lang="en-US"/>
               <a:t>Fifth level</a:t>
             </a:r>
-          </a:p>
-        </p:txBody>
-      </p:sp>
-      <p:sp>
-        <p:nvSpPr>
-          <p:cNvPr id="7" name="Date Placeholder 6">
-            <a:extLst>
-              <a:ext uri="{FF2B5EF4-FFF2-40B4-BE49-F238E27FC236}">
-                <a16:creationId xmlns:a16="http://schemas.microsoft.com/office/drawing/2014/main" id="{C4BC81CA-D2AD-AED1-7EF9-7DCC0931A468}"/>
-              </a:ext>
-            </a:extLst>
-          </p:cNvPr>
+            <a:endParaRPr lang="en-US" dirty="0"/>
+          </a:p>
+        </p:txBody>
+      </p:sp>
+      <p:sp>
+        <p:nvSpPr>
+          <p:cNvPr id="7" name="Date Placeholder 6"/>
           <p:cNvSpPr>
             <a:spLocks noGrp="1"/>
           </p:cNvSpPr>
@@ -1816,7 +1614,7 @@
           <a:p>
             <a:fld id="{32EB2BEB-40F2-354C-A8DB-62B53C266708}" type="datetimeFigureOut">
               <a:rPr lang="en-US" smtClean="0"/>
-              <a:t>3/19/26</a:t>
+              <a:t>4/7/26</a:t>
             </a:fld>
             <a:endParaRPr lang="en-US"/>
           </a:p>
@@ -1824,13 +1622,7 @@
       </p:sp>
       <p:sp>
         <p:nvSpPr>
-          <p:cNvPr id="8" name="Footer Placeholder 7">
-            <a:extLst>
-              <a:ext uri="{FF2B5EF4-FFF2-40B4-BE49-F238E27FC236}">
-                <a16:creationId xmlns:a16="http://schemas.microsoft.com/office/drawing/2014/main" id="{C70EDAAC-9597-2D73-591A-B312C91D52F0}"/>
-              </a:ext>
-            </a:extLst>
-          </p:cNvPr>
+          <p:cNvPr id="8" name="Footer Placeholder 7"/>
           <p:cNvSpPr>
             <a:spLocks noGrp="1"/>
           </p:cNvSpPr>
@@ -1849,13 +1641,7 @@
       </p:sp>
       <p:sp>
         <p:nvSpPr>
-          <p:cNvPr id="9" name="Slide Number Placeholder 8">
-            <a:extLst>
-              <a:ext uri="{FF2B5EF4-FFF2-40B4-BE49-F238E27FC236}">
-                <a16:creationId xmlns:a16="http://schemas.microsoft.com/office/drawing/2014/main" id="{0E707F05-03F3-8BC9-337D-200282E6DD12}"/>
-              </a:ext>
-            </a:extLst>
-          </p:cNvPr>
+          <p:cNvPr id="9" name="Slide Number Placeholder 8"/>
           <p:cNvSpPr>
             <a:spLocks noGrp="1"/>
           </p:cNvSpPr>
@@ -1879,7 +1665,7 @@
     </p:spTree>
     <p:extLst>
       <p:ext uri="{BB962C8B-B14F-4D97-AF65-F5344CB8AC3E}">
-        <p14:creationId xmlns:p14="http://schemas.microsoft.com/office/powerpoint/2010/main" val="2057038225"/>
+        <p14:creationId xmlns:p14="http://schemas.microsoft.com/office/powerpoint/2010/main" val="2142552435"/>
       </p:ext>
     </p:extLst>
   </p:cSld>
@@ -1908,13 +1694,7 @@
       </p:grpSpPr>
       <p:sp>
         <p:nvSpPr>
-          <p:cNvPr id="2" name="Title 1">
-            <a:extLst>
-              <a:ext uri="{FF2B5EF4-FFF2-40B4-BE49-F238E27FC236}">
-                <a16:creationId xmlns:a16="http://schemas.microsoft.com/office/drawing/2014/main" id="{B93A8306-6F0F-CACA-E5B6-57D9C9CAD9AD}"/>
-              </a:ext>
-            </a:extLst>
-          </p:cNvPr>
+          <p:cNvPr id="2" name="Title 1"/>
           <p:cNvSpPr>
             <a:spLocks noGrp="1"/>
           </p:cNvSpPr>
@@ -1931,18 +1711,13 @@
               <a:rPr lang="en-US"/>
               <a:t>Click to edit Master title style</a:t>
             </a:r>
-          </a:p>
-        </p:txBody>
-      </p:sp>
-      <p:sp>
-        <p:nvSpPr>
-          <p:cNvPr id="3" name="Date Placeholder 2">
-            <a:extLst>
-              <a:ext uri="{FF2B5EF4-FFF2-40B4-BE49-F238E27FC236}">
-                <a16:creationId xmlns:a16="http://schemas.microsoft.com/office/drawing/2014/main" id="{773F9D11-070E-1A11-2F68-7A89D86B3C1E}"/>
-              </a:ext>
-            </a:extLst>
-          </p:cNvPr>
+            <a:endParaRPr lang="en-US" dirty="0"/>
+          </a:p>
+        </p:txBody>
+      </p:sp>
+      <p:sp>
+        <p:nvSpPr>
+          <p:cNvPr id="3" name="Date Placeholder 2"/>
           <p:cNvSpPr>
             <a:spLocks noGrp="1"/>
           </p:cNvSpPr>
@@ -1957,7 +1732,7 @@
           <a:p>
             <a:fld id="{32EB2BEB-40F2-354C-A8DB-62B53C266708}" type="datetimeFigureOut">
               <a:rPr lang="en-US" smtClean="0"/>
-              <a:t>3/19/26</a:t>
+              <a:t>4/7/26</a:t>
             </a:fld>
             <a:endParaRPr lang="en-US"/>
           </a:p>
@@ -1965,13 +1740,7 @@
       </p:sp>
       <p:sp>
         <p:nvSpPr>
-          <p:cNvPr id="4" name="Footer Placeholder 3">
-            <a:extLst>
-              <a:ext uri="{FF2B5EF4-FFF2-40B4-BE49-F238E27FC236}">
-                <a16:creationId xmlns:a16="http://schemas.microsoft.com/office/drawing/2014/main" id="{71D543D1-CFAB-BCAB-9077-894BF195BE7D}"/>
-              </a:ext>
-            </a:extLst>
-          </p:cNvPr>
+          <p:cNvPr id="4" name="Footer Placeholder 3"/>
           <p:cNvSpPr>
             <a:spLocks noGrp="1"/>
           </p:cNvSpPr>
@@ -1990,13 +1759,7 @@
       </p:sp>
       <p:sp>
         <p:nvSpPr>
-          <p:cNvPr id="5" name="Slide Number Placeholder 4">
-            <a:extLst>
-              <a:ext uri="{FF2B5EF4-FFF2-40B4-BE49-F238E27FC236}">
-                <a16:creationId xmlns:a16="http://schemas.microsoft.com/office/drawing/2014/main" id="{7F8E8112-06E6-B317-492D-065A4A389C95}"/>
-              </a:ext>
-            </a:extLst>
-          </p:cNvPr>
+          <p:cNvPr id="5" name="Slide Number Placeholder 4"/>
           <p:cNvSpPr>
             <a:spLocks noGrp="1"/>
           </p:cNvSpPr>
@@ -2020,7 +1783,7 @@
     </p:spTree>
     <p:extLst>
       <p:ext uri="{BB962C8B-B14F-4D97-AF65-F5344CB8AC3E}">
-        <p14:creationId xmlns:p14="http://schemas.microsoft.com/office/powerpoint/2010/main" val="3141259525"/>
+        <p14:creationId xmlns:p14="http://schemas.microsoft.com/office/powerpoint/2010/main" val="1414331528"/>
       </p:ext>
     </p:extLst>
   </p:cSld>
@@ -2049,13 +1812,7 @@
       </p:grpSpPr>
       <p:sp>
         <p:nvSpPr>
-          <p:cNvPr id="2" name="Date Placeholder 1">
-            <a:extLst>
-              <a:ext uri="{FF2B5EF4-FFF2-40B4-BE49-F238E27FC236}">
-                <a16:creationId xmlns:a16="http://schemas.microsoft.com/office/drawing/2014/main" id="{F9878695-5473-2144-A1AB-FC1792758BE1}"/>
-              </a:ext>
-            </a:extLst>
-          </p:cNvPr>
+          <p:cNvPr id="2" name="Date Placeholder 1"/>
           <p:cNvSpPr>
             <a:spLocks noGrp="1"/>
           </p:cNvSpPr>
@@ -2070,7 +1827,7 @@
           <a:p>
             <a:fld id="{32EB2BEB-40F2-354C-A8DB-62B53C266708}" type="datetimeFigureOut">
               <a:rPr lang="en-US" smtClean="0"/>
-              <a:t>3/19/26</a:t>
+              <a:t>4/7/26</a:t>
             </a:fld>
             <a:endParaRPr lang="en-US"/>
           </a:p>
@@ -2078,13 +1835,7 @@
       </p:sp>
       <p:sp>
         <p:nvSpPr>
-          <p:cNvPr id="3" name="Footer Placeholder 2">
-            <a:extLst>
-              <a:ext uri="{FF2B5EF4-FFF2-40B4-BE49-F238E27FC236}">
-                <a16:creationId xmlns:a16="http://schemas.microsoft.com/office/drawing/2014/main" id="{BDB7D109-1162-B84D-975E-3019C6A42929}"/>
-              </a:ext>
-            </a:extLst>
-          </p:cNvPr>
+          <p:cNvPr id="3" name="Footer Placeholder 2"/>
           <p:cNvSpPr>
             <a:spLocks noGrp="1"/>
           </p:cNvSpPr>
@@ -2103,13 +1854,7 @@
       </p:sp>
       <p:sp>
         <p:nvSpPr>
-          <p:cNvPr id="4" name="Slide Number Placeholder 3">
-            <a:extLst>
-              <a:ext uri="{FF2B5EF4-FFF2-40B4-BE49-F238E27FC236}">
-                <a16:creationId xmlns:a16="http://schemas.microsoft.com/office/drawing/2014/main" id="{17EB6319-FA21-BA53-EE9D-B1539F81726B}"/>
-              </a:ext>
-            </a:extLst>
-          </p:cNvPr>
+          <p:cNvPr id="4" name="Slide Number Placeholder 3"/>
           <p:cNvSpPr>
             <a:spLocks noGrp="1"/>
           </p:cNvSpPr>
@@ -2133,7 +1878,7 @@
     </p:spTree>
     <p:extLst>
       <p:ext uri="{BB962C8B-B14F-4D97-AF65-F5344CB8AC3E}">
-        <p14:creationId xmlns:p14="http://schemas.microsoft.com/office/powerpoint/2010/main" val="242563948"/>
+        <p14:creationId xmlns:p14="http://schemas.microsoft.com/office/powerpoint/2010/main" val="632185072"/>
       </p:ext>
     </p:extLst>
   </p:cSld>
@@ -2162,13 +1907,7 @@
       </p:grpSpPr>
       <p:sp>
         <p:nvSpPr>
-          <p:cNvPr id="2" name="Title 1">
-            <a:extLst>
-              <a:ext uri="{FF2B5EF4-FFF2-40B4-BE49-F238E27FC236}">
-                <a16:creationId xmlns:a16="http://schemas.microsoft.com/office/drawing/2014/main" id="{77FD7C67-E9DA-FECC-8EEB-F2A6E0829EB8}"/>
-              </a:ext>
-            </a:extLst>
-          </p:cNvPr>
+          <p:cNvPr id="2" name="Title 1"/>
           <p:cNvSpPr>
             <a:spLocks noGrp="1"/>
           </p:cNvSpPr>
@@ -2178,15 +1917,15 @@
         </p:nvSpPr>
         <p:spPr>
           <a:xfrm>
-            <a:off x="839788" y="457200"/>
-            <a:ext cx="3932237" cy="1600200"/>
+            <a:off x="2099253" y="1016212"/>
+            <a:ext cx="9829568" cy="3556741"/>
           </a:xfrm>
         </p:spPr>
         <p:txBody>
           <a:bodyPr anchor="b"/>
           <a:lstStyle>
             <a:lvl1pPr>
-              <a:defRPr sz="3200"/>
+              <a:defRPr sz="7113"/>
             </a:lvl1pPr>
           </a:lstStyle>
           <a:p>
@@ -2194,18 +1933,13 @@
               <a:rPr lang="en-US"/>
               <a:t>Click to edit Master title style</a:t>
             </a:r>
-          </a:p>
-        </p:txBody>
-      </p:sp>
-      <p:sp>
-        <p:nvSpPr>
-          <p:cNvPr id="3" name="Content Placeholder 2">
-            <a:extLst>
-              <a:ext uri="{FF2B5EF4-FFF2-40B4-BE49-F238E27FC236}">
-                <a16:creationId xmlns:a16="http://schemas.microsoft.com/office/drawing/2014/main" id="{A00BFFF9-44FD-2CB8-8959-6E7CE0C6CB7B}"/>
-              </a:ext>
-            </a:extLst>
-          </p:cNvPr>
+            <a:endParaRPr lang="en-US" dirty="0"/>
+          </a:p>
+        </p:txBody>
+      </p:sp>
+      <p:sp>
+        <p:nvSpPr>
+          <p:cNvPr id="3" name="Content Placeholder 2"/>
           <p:cNvSpPr>
             <a:spLocks noGrp="1"/>
           </p:cNvSpPr>
@@ -2215,39 +1949,39 @@
         </p:nvSpPr>
         <p:spPr>
           <a:xfrm>
-            <a:off x="5183188" y="987425"/>
-            <a:ext cx="6172200" cy="4873625"/>
+            <a:off x="12956620" y="2194736"/>
+            <a:ext cx="15428893" cy="10832534"/>
           </a:xfrm>
         </p:spPr>
         <p:txBody>
           <a:bodyPr/>
           <a:lstStyle>
             <a:lvl1pPr>
-              <a:defRPr sz="3200"/>
+              <a:defRPr sz="7113"/>
             </a:lvl1pPr>
             <a:lvl2pPr>
-              <a:defRPr sz="2800"/>
+              <a:defRPr sz="6224"/>
             </a:lvl2pPr>
             <a:lvl3pPr>
-              <a:defRPr sz="2400"/>
+              <a:defRPr sz="5334"/>
             </a:lvl3pPr>
             <a:lvl4pPr>
-              <a:defRPr sz="2000"/>
+              <a:defRPr sz="4445"/>
             </a:lvl4pPr>
             <a:lvl5pPr>
-              <a:defRPr sz="2000"/>
+              <a:defRPr sz="4445"/>
             </a:lvl5pPr>
             <a:lvl6pPr>
-              <a:defRPr sz="2000"/>
+              <a:defRPr sz="4445"/>
             </a:lvl6pPr>
             <a:lvl7pPr>
-              <a:defRPr sz="2000"/>
+              <a:defRPr sz="4445"/>
             </a:lvl7pPr>
             <a:lvl8pPr>
-              <a:defRPr sz="2000"/>
+              <a:defRPr sz="4445"/>
             </a:lvl8pPr>
             <a:lvl9pPr>
-              <a:defRPr sz="2000"/>
+              <a:defRPr sz="4445"/>
             </a:lvl9pPr>
           </a:lstStyle>
           <a:p>
@@ -2284,18 +2018,13 @@
               <a:rPr lang="en-US"/>
               <a:t>Fifth level</a:t>
             </a:r>
-          </a:p>
-        </p:txBody>
-      </p:sp>
-      <p:sp>
-        <p:nvSpPr>
-          <p:cNvPr id="4" name="Text Placeholder 3">
-            <a:extLst>
-              <a:ext uri="{FF2B5EF4-FFF2-40B4-BE49-F238E27FC236}">
-                <a16:creationId xmlns:a16="http://schemas.microsoft.com/office/drawing/2014/main" id="{8D15483F-D2E6-68F3-523D-007C01011315}"/>
-              </a:ext>
-            </a:extLst>
-          </p:cNvPr>
+            <a:endParaRPr lang="en-US" dirty="0"/>
+          </a:p>
+        </p:txBody>
+      </p:sp>
+      <p:sp>
+        <p:nvSpPr>
+          <p:cNvPr id="4" name="Text Placeholder 3"/>
           <p:cNvSpPr>
             <a:spLocks noGrp="1"/>
           </p:cNvSpPr>
@@ -2305,8 +2034,8 @@
         </p:nvSpPr>
         <p:spPr>
           <a:xfrm>
-            <a:off x="839788" y="2057400"/>
-            <a:ext cx="3932237" cy="3811588"/>
+            <a:off x="2099253" y="4572953"/>
+            <a:ext cx="9829568" cy="8471960"/>
           </a:xfrm>
         </p:spPr>
         <p:txBody>
@@ -2314,39 +2043,39 @@
           <a:lstStyle>
             <a:lvl1pPr marL="0" indent="0">
               <a:buNone/>
-              <a:defRPr sz="1600"/>
+              <a:defRPr sz="3556"/>
             </a:lvl1pPr>
-            <a:lvl2pPr marL="457200" indent="0">
-              <a:buNone/>
-              <a:defRPr sz="1400"/>
+            <a:lvl2pPr marL="1016218" indent="0">
+              <a:buNone/>
+              <a:defRPr sz="3112"/>
             </a:lvl2pPr>
-            <a:lvl3pPr marL="914400" indent="0">
-              <a:buNone/>
-              <a:defRPr sz="1200"/>
+            <a:lvl3pPr marL="2032437" indent="0">
+              <a:buNone/>
+              <a:defRPr sz="2667"/>
             </a:lvl3pPr>
-            <a:lvl4pPr marL="1371600" indent="0">
-              <a:buNone/>
-              <a:defRPr sz="1000"/>
+            <a:lvl4pPr marL="3048655" indent="0">
+              <a:buNone/>
+              <a:defRPr sz="2223"/>
             </a:lvl4pPr>
-            <a:lvl5pPr marL="1828800" indent="0">
-              <a:buNone/>
-              <a:defRPr sz="1000"/>
+            <a:lvl5pPr marL="4064874" indent="0">
+              <a:buNone/>
+              <a:defRPr sz="2223"/>
             </a:lvl5pPr>
-            <a:lvl6pPr marL="2286000" indent="0">
-              <a:buNone/>
-              <a:defRPr sz="1000"/>
+            <a:lvl6pPr marL="5081092" indent="0">
+              <a:buNone/>
+              <a:defRPr sz="2223"/>
             </a:lvl6pPr>
-            <a:lvl7pPr marL="2743200" indent="0">
-              <a:buNone/>
-              <a:defRPr sz="1000"/>
+            <a:lvl7pPr marL="6097311" indent="0">
+              <a:buNone/>
+              <a:defRPr sz="2223"/>
             </a:lvl7pPr>
-            <a:lvl8pPr marL="3200400" indent="0">
-              <a:buNone/>
-              <a:defRPr sz="1000"/>
+            <a:lvl8pPr marL="7113529" indent="0">
+              <a:buNone/>
+              <a:defRPr sz="2223"/>
             </a:lvl8pPr>
-            <a:lvl9pPr marL="3657600" indent="0">
-              <a:buNone/>
-              <a:defRPr sz="1000"/>
+            <a:lvl9pPr marL="8129748" indent="0">
+              <a:buNone/>
+              <a:defRPr sz="2223"/>
             </a:lvl9pPr>
           </a:lstStyle>
           <a:p>
@@ -2360,13 +2089,7 @@
       </p:sp>
       <p:sp>
         <p:nvSpPr>
-          <p:cNvPr id="5" name="Date Placeholder 4">
-            <a:extLst>
-              <a:ext uri="{FF2B5EF4-FFF2-40B4-BE49-F238E27FC236}">
-                <a16:creationId xmlns:a16="http://schemas.microsoft.com/office/drawing/2014/main" id="{3F41FEAC-29F0-B6CB-710E-64CE2528D467}"/>
-              </a:ext>
-            </a:extLst>
-          </p:cNvPr>
+          <p:cNvPr id="5" name="Date Placeholder 4"/>
           <p:cNvSpPr>
             <a:spLocks noGrp="1"/>
           </p:cNvSpPr>
@@ -2381,7 +2104,7 @@
           <a:p>
             <a:fld id="{32EB2BEB-40F2-354C-A8DB-62B53C266708}" type="datetimeFigureOut">
               <a:rPr lang="en-US" smtClean="0"/>
-              <a:t>3/19/26</a:t>
+              <a:t>4/7/26</a:t>
             </a:fld>
             <a:endParaRPr lang="en-US"/>
           </a:p>
@@ -2389,13 +2112,7 @@
       </p:sp>
       <p:sp>
         <p:nvSpPr>
-          <p:cNvPr id="6" name="Footer Placeholder 5">
-            <a:extLst>
-              <a:ext uri="{FF2B5EF4-FFF2-40B4-BE49-F238E27FC236}">
-                <a16:creationId xmlns:a16="http://schemas.microsoft.com/office/drawing/2014/main" id="{3A2FD848-F290-637A-50A6-DDD05EBA3AD5}"/>
-              </a:ext>
-            </a:extLst>
-          </p:cNvPr>
+          <p:cNvPr id="6" name="Footer Placeholder 5"/>
           <p:cNvSpPr>
             <a:spLocks noGrp="1"/>
           </p:cNvSpPr>
@@ -2414,13 +2131,7 @@
       </p:sp>
       <p:sp>
         <p:nvSpPr>
-          <p:cNvPr id="7" name="Slide Number Placeholder 6">
-            <a:extLst>
-              <a:ext uri="{FF2B5EF4-FFF2-40B4-BE49-F238E27FC236}">
-                <a16:creationId xmlns:a16="http://schemas.microsoft.com/office/drawing/2014/main" id="{4E2206AD-895C-D1C2-07E4-78B2E6F67A9C}"/>
-              </a:ext>
-            </a:extLst>
-          </p:cNvPr>
+          <p:cNvPr id="7" name="Slide Number Placeholder 6"/>
           <p:cNvSpPr>
             <a:spLocks noGrp="1"/>
           </p:cNvSpPr>
@@ -2444,7 +2155,7 @@
     </p:spTree>
     <p:extLst>
       <p:ext uri="{BB962C8B-B14F-4D97-AF65-F5344CB8AC3E}">
-        <p14:creationId xmlns:p14="http://schemas.microsoft.com/office/powerpoint/2010/main" val="375000124"/>
+        <p14:creationId xmlns:p14="http://schemas.microsoft.com/office/powerpoint/2010/main" val="2847885642"/>
       </p:ext>
     </p:extLst>
   </p:cSld>
@@ -2473,13 +2184,7 @@
       </p:grpSpPr>
       <p:sp>
         <p:nvSpPr>
-          <p:cNvPr id="2" name="Title 1">
-            <a:extLst>
-              <a:ext uri="{FF2B5EF4-FFF2-40B4-BE49-F238E27FC236}">
-                <a16:creationId xmlns:a16="http://schemas.microsoft.com/office/drawing/2014/main" id="{85869A4D-BF85-643F-FD3B-A5D8A32DF1AF}"/>
-              </a:ext>
-            </a:extLst>
-          </p:cNvPr>
+          <p:cNvPr id="2" name="Title 1"/>
           <p:cNvSpPr>
             <a:spLocks noGrp="1"/>
           </p:cNvSpPr>
@@ -2489,15 +2194,15 @@
         </p:nvSpPr>
         <p:spPr>
           <a:xfrm>
-            <a:off x="839788" y="457200"/>
-            <a:ext cx="3932237" cy="1600200"/>
+            <a:off x="2099253" y="1016212"/>
+            <a:ext cx="9829568" cy="3556741"/>
           </a:xfrm>
         </p:spPr>
         <p:txBody>
           <a:bodyPr anchor="b"/>
           <a:lstStyle>
             <a:lvl1pPr>
-              <a:defRPr sz="3200"/>
+              <a:defRPr sz="7113"/>
             </a:lvl1pPr>
           </a:lstStyle>
           <a:p>
@@ -2505,20 +2210,15 @@
               <a:rPr lang="en-US"/>
               <a:t>Click to edit Master title style</a:t>
             </a:r>
-          </a:p>
-        </p:txBody>
-      </p:sp>
-      <p:sp>
-        <p:nvSpPr>
-          <p:cNvPr id="3" name="Picture Placeholder 2">
-            <a:extLst>
-              <a:ext uri="{FF2B5EF4-FFF2-40B4-BE49-F238E27FC236}">
-                <a16:creationId xmlns:a16="http://schemas.microsoft.com/office/drawing/2014/main" id="{B4DA6F92-29B5-8AC0-2DC1-88C17B50FCBC}"/>
-              </a:ext>
-            </a:extLst>
-          </p:cNvPr>
-          <p:cNvSpPr>
-            <a:spLocks noGrp="1"/>
+            <a:endParaRPr lang="en-US" dirty="0"/>
+          </a:p>
+        </p:txBody>
+      </p:sp>
+      <p:sp>
+        <p:nvSpPr>
+          <p:cNvPr id="3" name="Picture Placeholder 2"/>
+          <p:cNvSpPr>
+            <a:spLocks noGrp="1" noChangeAspect="1"/>
           </p:cNvSpPr>
           <p:nvPr>
             <p:ph type="pic" idx="1"/>
@@ -2526,64 +2226,62 @@
         </p:nvSpPr>
         <p:spPr>
           <a:xfrm>
-            <a:off x="5183188" y="987425"/>
-            <a:ext cx="6172200" cy="4873625"/>
+            <a:off x="12956620" y="2194736"/>
+            <a:ext cx="15428893" cy="10832534"/>
           </a:xfrm>
         </p:spPr>
         <p:txBody>
-          <a:bodyPr/>
+          <a:bodyPr anchor="t"/>
           <a:lstStyle>
             <a:lvl1pPr marL="0" indent="0">
               <a:buNone/>
-              <a:defRPr sz="3200"/>
+              <a:defRPr sz="7113"/>
             </a:lvl1pPr>
-            <a:lvl2pPr marL="457200" indent="0">
-              <a:buNone/>
-              <a:defRPr sz="2800"/>
+            <a:lvl2pPr marL="1016218" indent="0">
+              <a:buNone/>
+              <a:defRPr sz="6224"/>
             </a:lvl2pPr>
-            <a:lvl3pPr marL="914400" indent="0">
-              <a:buNone/>
-              <a:defRPr sz="2400"/>
+            <a:lvl3pPr marL="2032437" indent="0">
+              <a:buNone/>
+              <a:defRPr sz="5334"/>
             </a:lvl3pPr>
-            <a:lvl4pPr marL="1371600" indent="0">
-              <a:buNone/>
-              <a:defRPr sz="2000"/>
+            <a:lvl4pPr marL="3048655" indent="0">
+              <a:buNone/>
+              <a:defRPr sz="4445"/>
             </a:lvl4pPr>
-            <a:lvl5pPr marL="1828800" indent="0">
-              <a:buNone/>
-              <a:defRPr sz="2000"/>
+            <a:lvl5pPr marL="4064874" indent="0">
+              <a:buNone/>
+              <a:defRPr sz="4445"/>
             </a:lvl5pPr>
-            <a:lvl6pPr marL="2286000" indent="0">
-              <a:buNone/>
-              <a:defRPr sz="2000"/>
+            <a:lvl6pPr marL="5081092" indent="0">
+              <a:buNone/>
+              <a:defRPr sz="4445"/>
             </a:lvl6pPr>
-            <a:lvl7pPr marL="2743200" indent="0">
-              <a:buNone/>
-              <a:defRPr sz="2000"/>
+            <a:lvl7pPr marL="6097311" indent="0">
+              <a:buNone/>
+              <a:defRPr sz="4445"/>
             </a:lvl7pPr>
-            <a:lvl8pPr marL="3200400" indent="0">
-              <a:buNone/>
-              <a:defRPr sz="2000"/>
+            <a:lvl8pPr marL="7113529" indent="0">
+              <a:buNone/>
+              <a:defRPr sz="4445"/>
             </a:lvl8pPr>
-            <a:lvl9pPr marL="3657600" indent="0">
-              <a:buNone/>
-              <a:defRPr sz="2000"/>
+            <a:lvl9pPr marL="8129748" indent="0">
+              <a:buNone/>
+              <a:defRPr sz="4445"/>
             </a:lvl9pPr>
           </a:lstStyle>
           <a:p>
-            <a:endParaRPr lang="en-US"/>
-          </a:p>
-        </p:txBody>
-      </p:sp>
-      <p:sp>
-        <p:nvSpPr>
-          <p:cNvPr id="4" name="Text Placeholder 3">
-            <a:extLst>
-              <a:ext uri="{FF2B5EF4-FFF2-40B4-BE49-F238E27FC236}">
-                <a16:creationId xmlns:a16="http://schemas.microsoft.com/office/drawing/2014/main" id="{578AF8F3-DE96-7A35-658C-E047EC12D7C5}"/>
-              </a:ext>
-            </a:extLst>
-          </p:cNvPr>
+            <a:r>
+              <a:rPr lang="en-US"/>
+              <a:t>Click icon to add picture</a:t>
+            </a:r>
+            <a:endParaRPr lang="en-US" dirty="0"/>
+          </a:p>
+        </p:txBody>
+      </p:sp>
+      <p:sp>
+        <p:nvSpPr>
+          <p:cNvPr id="4" name="Text Placeholder 3"/>
           <p:cNvSpPr>
             <a:spLocks noGrp="1"/>
           </p:cNvSpPr>
@@ -2593,8 +2291,8 @@
         </p:nvSpPr>
         <p:spPr>
           <a:xfrm>
-            <a:off x="839788" y="2057400"/>
-            <a:ext cx="3932237" cy="3811588"/>
+            <a:off x="2099253" y="4572953"/>
+            <a:ext cx="9829568" cy="8471960"/>
           </a:xfrm>
         </p:spPr>
         <p:txBody>
@@ -2602,39 +2300,39 @@
           <a:lstStyle>
             <a:lvl1pPr marL="0" indent="0">
               <a:buNone/>
-              <a:defRPr sz="1600"/>
+              <a:defRPr sz="3556"/>
             </a:lvl1pPr>
-            <a:lvl2pPr marL="457200" indent="0">
-              <a:buNone/>
-              <a:defRPr sz="1400"/>
+            <a:lvl2pPr marL="1016218" indent="0">
+              <a:buNone/>
+              <a:defRPr sz="3112"/>
             </a:lvl2pPr>
-            <a:lvl3pPr marL="914400" indent="0">
-              <a:buNone/>
-              <a:defRPr sz="1200"/>
+            <a:lvl3pPr marL="2032437" indent="0">
+              <a:buNone/>
+              <a:defRPr sz="2667"/>
             </a:lvl3pPr>
-            <a:lvl4pPr marL="1371600" indent="0">
-              <a:buNone/>
-              <a:defRPr sz="1000"/>
+            <a:lvl4pPr marL="3048655" indent="0">
+              <a:buNone/>
+              <a:defRPr sz="2223"/>
             </a:lvl4pPr>
-            <a:lvl5pPr marL="1828800" indent="0">
-              <a:buNone/>
-              <a:defRPr sz="1000"/>
+            <a:lvl5pPr marL="4064874" indent="0">
+              <a:buNone/>
+              <a:defRPr sz="2223"/>
             </a:lvl5pPr>
-            <a:lvl6pPr marL="2286000" indent="0">
-              <a:buNone/>
-              <a:defRPr sz="1000"/>
+            <a:lvl6pPr marL="5081092" indent="0">
+              <a:buNone/>
+              <a:defRPr sz="2223"/>
             </a:lvl6pPr>
-            <a:lvl7pPr marL="2743200" indent="0">
-              <a:buNone/>
-              <a:defRPr sz="1000"/>
+            <a:lvl7pPr marL="6097311" indent="0">
+              <a:buNone/>
+              <a:defRPr sz="2223"/>
             </a:lvl7pPr>
-            <a:lvl8pPr marL="3200400" indent="0">
-              <a:buNone/>
-              <a:defRPr sz="1000"/>
+            <a:lvl8pPr marL="7113529" indent="0">
+              <a:buNone/>
+              <a:defRPr sz="2223"/>
             </a:lvl8pPr>
-            <a:lvl9pPr marL="3657600" indent="0">
-              <a:buNone/>
-              <a:defRPr sz="1000"/>
+            <a:lvl9pPr marL="8129748" indent="0">
+              <a:buNone/>
+              <a:defRPr sz="2223"/>
             </a:lvl9pPr>
           </a:lstStyle>
           <a:p>
@@ -2648,13 +2346,7 @@
       </p:sp>
       <p:sp>
         <p:nvSpPr>
-          <p:cNvPr id="5" name="Date Placeholder 4">
-            <a:extLst>
-              <a:ext uri="{FF2B5EF4-FFF2-40B4-BE49-F238E27FC236}">
-                <a16:creationId xmlns:a16="http://schemas.microsoft.com/office/drawing/2014/main" id="{1326248C-210F-A0BF-BE94-1FCB4C7C206B}"/>
-              </a:ext>
-            </a:extLst>
-          </p:cNvPr>
+          <p:cNvPr id="5" name="Date Placeholder 4"/>
           <p:cNvSpPr>
             <a:spLocks noGrp="1"/>
           </p:cNvSpPr>
@@ -2669,7 +2361,7 @@
           <a:p>
             <a:fld id="{32EB2BEB-40F2-354C-A8DB-62B53C266708}" type="datetimeFigureOut">
               <a:rPr lang="en-US" smtClean="0"/>
-              <a:t>3/19/26</a:t>
+              <a:t>4/7/26</a:t>
             </a:fld>
             <a:endParaRPr lang="en-US"/>
           </a:p>
@@ -2677,13 +2369,7 @@
       </p:sp>
       <p:sp>
         <p:nvSpPr>
-          <p:cNvPr id="6" name="Footer Placeholder 5">
-            <a:extLst>
-              <a:ext uri="{FF2B5EF4-FFF2-40B4-BE49-F238E27FC236}">
-                <a16:creationId xmlns:a16="http://schemas.microsoft.com/office/drawing/2014/main" id="{CD7C9094-650C-66E3-1AB1-823E9D94882D}"/>
-              </a:ext>
-            </a:extLst>
-          </p:cNvPr>
+          <p:cNvPr id="6" name="Footer Placeholder 5"/>
           <p:cNvSpPr>
             <a:spLocks noGrp="1"/>
           </p:cNvSpPr>
@@ -2702,13 +2388,7 @@
       </p:sp>
       <p:sp>
         <p:nvSpPr>
-          <p:cNvPr id="7" name="Slide Number Placeholder 6">
-            <a:extLst>
-              <a:ext uri="{FF2B5EF4-FFF2-40B4-BE49-F238E27FC236}">
-                <a16:creationId xmlns:a16="http://schemas.microsoft.com/office/drawing/2014/main" id="{BBDF1616-AB76-F56F-36C8-AEE1D0A623A8}"/>
-              </a:ext>
-            </a:extLst>
-          </p:cNvPr>
+          <p:cNvPr id="7" name="Slide Number Placeholder 6"/>
           <p:cNvSpPr>
             <a:spLocks noGrp="1"/>
           </p:cNvSpPr>
@@ -2732,7 +2412,7 @@
     </p:spTree>
     <p:extLst>
       <p:ext uri="{BB962C8B-B14F-4D97-AF65-F5344CB8AC3E}">
-        <p14:creationId xmlns:p14="http://schemas.microsoft.com/office/powerpoint/2010/main" val="1404577018"/>
+        <p14:creationId xmlns:p14="http://schemas.microsoft.com/office/powerpoint/2010/main" val="3540834528"/>
       </p:ext>
     </p:extLst>
   </p:cSld>
@@ -2766,13 +2446,7 @@
       </p:grpSpPr>
       <p:sp>
         <p:nvSpPr>
-          <p:cNvPr id="2" name="Title Placeholder 1">
-            <a:extLst>
-              <a:ext uri="{FF2B5EF4-FFF2-40B4-BE49-F238E27FC236}">
-                <a16:creationId xmlns:a16="http://schemas.microsoft.com/office/drawing/2014/main" id="{DC938387-7195-7008-779B-4C1FB5EC1900}"/>
-              </a:ext>
-            </a:extLst>
-          </p:cNvPr>
+          <p:cNvPr id="2" name="Title Placeholder 1"/>
           <p:cNvSpPr>
             <a:spLocks noGrp="1"/>
           </p:cNvSpPr>
@@ -2782,8 +2456,8 @@
         </p:nvSpPr>
         <p:spPr>
           <a:xfrm>
-            <a:off x="838200" y="365125"/>
-            <a:ext cx="10515600" cy="1325563"/>
+            <a:off x="2095282" y="811559"/>
+            <a:ext cx="26286262" cy="2946309"/>
           </a:xfrm>
           <a:prstGeom prst="rect">
             <a:avLst/>
@@ -2799,18 +2473,13 @@
               <a:rPr lang="en-US"/>
               <a:t>Click to edit Master title style</a:t>
             </a:r>
-          </a:p>
-        </p:txBody>
-      </p:sp>
-      <p:sp>
-        <p:nvSpPr>
-          <p:cNvPr id="3" name="Text Placeholder 2">
-            <a:extLst>
-              <a:ext uri="{FF2B5EF4-FFF2-40B4-BE49-F238E27FC236}">
-                <a16:creationId xmlns:a16="http://schemas.microsoft.com/office/drawing/2014/main" id="{CEB24289-5B6F-9E73-0636-FE72E659F913}"/>
-              </a:ext>
-            </a:extLst>
-          </p:cNvPr>
+            <a:endParaRPr lang="en-US" dirty="0"/>
+          </a:p>
+        </p:txBody>
+      </p:sp>
+      <p:sp>
+        <p:nvSpPr>
+          <p:cNvPr id="3" name="Text Placeholder 2"/>
           <p:cNvSpPr>
             <a:spLocks noGrp="1"/>
           </p:cNvSpPr>
@@ -2820,8 +2489,8 @@
         </p:nvSpPr>
         <p:spPr>
           <a:xfrm>
-            <a:off x="838200" y="1825625"/>
-            <a:ext cx="10515600" cy="4351338"/>
+            <a:off x="2095282" y="4057789"/>
+            <a:ext cx="26286262" cy="9671655"/>
           </a:xfrm>
           <a:prstGeom prst="rect">
             <a:avLst/>
@@ -2866,18 +2535,13 @@
               <a:rPr lang="en-US"/>
               <a:t>Fifth level</a:t>
             </a:r>
-          </a:p>
-        </p:txBody>
-      </p:sp>
-      <p:sp>
-        <p:nvSpPr>
-          <p:cNvPr id="4" name="Date Placeholder 3">
-            <a:extLst>
-              <a:ext uri="{FF2B5EF4-FFF2-40B4-BE49-F238E27FC236}">
-                <a16:creationId xmlns:a16="http://schemas.microsoft.com/office/drawing/2014/main" id="{BDF6A95C-6A52-85A3-E987-6E5CB3BDA4CB}"/>
-              </a:ext>
-            </a:extLst>
-          </p:cNvPr>
+            <a:endParaRPr lang="en-US" dirty="0"/>
+          </a:p>
+        </p:txBody>
+      </p:sp>
+      <p:sp>
+        <p:nvSpPr>
+          <p:cNvPr id="4" name="Date Placeholder 3"/>
           <p:cNvSpPr>
             <a:spLocks noGrp="1"/>
           </p:cNvSpPr>
@@ -2887,8 +2551,8 @@
         </p:nvSpPr>
         <p:spPr>
           <a:xfrm>
-            <a:off x="838200" y="6356350"/>
-            <a:ext cx="2743200" cy="365125"/>
+            <a:off x="2095282" y="14128166"/>
+            <a:ext cx="6857286" cy="811558"/>
           </a:xfrm>
           <a:prstGeom prst="rect">
             <a:avLst/>
@@ -2898,7 +2562,7 @@
           <a:bodyPr vert="horz" lIns="91440" tIns="45720" rIns="91440" bIns="45720" rtlCol="0" anchor="ctr"/>
           <a:lstStyle>
             <a:lvl1pPr algn="l">
-              <a:defRPr sz="1200">
+              <a:defRPr sz="2667">
                 <a:solidFill>
                   <a:schemeClr val="tx1">
                     <a:tint val="82000"/>
@@ -2910,7 +2574,7 @@
           <a:p>
             <a:fld id="{32EB2BEB-40F2-354C-A8DB-62B53C266708}" type="datetimeFigureOut">
               <a:rPr lang="en-US" smtClean="0"/>
-              <a:t>3/19/26</a:t>
+              <a:t>4/7/26</a:t>
             </a:fld>
             <a:endParaRPr lang="en-US"/>
           </a:p>
@@ -2918,13 +2582,7 @@
       </p:sp>
       <p:sp>
         <p:nvSpPr>
-          <p:cNvPr id="5" name="Footer Placeholder 4">
-            <a:extLst>
-              <a:ext uri="{FF2B5EF4-FFF2-40B4-BE49-F238E27FC236}">
-                <a16:creationId xmlns:a16="http://schemas.microsoft.com/office/drawing/2014/main" id="{857A06E9-41DF-779F-70E9-6AC7C552091A}"/>
-              </a:ext>
-            </a:extLst>
-          </p:cNvPr>
+          <p:cNvPr id="5" name="Footer Placeholder 4"/>
           <p:cNvSpPr>
             <a:spLocks noGrp="1"/>
           </p:cNvSpPr>
@@ -2934,8 +2592,8 @@
         </p:nvSpPr>
         <p:spPr>
           <a:xfrm>
-            <a:off x="4038600" y="6356350"/>
-            <a:ext cx="4114800" cy="365125"/>
+            <a:off x="10095449" y="14128166"/>
+            <a:ext cx="10285928" cy="811558"/>
           </a:xfrm>
           <a:prstGeom prst="rect">
             <a:avLst/>
@@ -2945,7 +2603,7 @@
           <a:bodyPr vert="horz" lIns="91440" tIns="45720" rIns="91440" bIns="45720" rtlCol="0" anchor="ctr"/>
           <a:lstStyle>
             <a:lvl1pPr algn="ctr">
-              <a:defRPr sz="1200">
+              <a:defRPr sz="2667">
                 <a:solidFill>
                   <a:schemeClr val="tx1">
                     <a:tint val="82000"/>
@@ -2961,13 +2619,7 @@
       </p:sp>
       <p:sp>
         <p:nvSpPr>
-          <p:cNvPr id="6" name="Slide Number Placeholder 5">
-            <a:extLst>
-              <a:ext uri="{FF2B5EF4-FFF2-40B4-BE49-F238E27FC236}">
-                <a16:creationId xmlns:a16="http://schemas.microsoft.com/office/drawing/2014/main" id="{C73F835F-8C2D-0404-D61E-3AD201339A0E}"/>
-              </a:ext>
-            </a:extLst>
-          </p:cNvPr>
+          <p:cNvPr id="6" name="Slide Number Placeholder 5"/>
           <p:cNvSpPr>
             <a:spLocks noGrp="1"/>
           </p:cNvSpPr>
@@ -2977,8 +2629,8 @@
         </p:nvSpPr>
         <p:spPr>
           <a:xfrm>
-            <a:off x="8610600" y="6356350"/>
-            <a:ext cx="2743200" cy="365125"/>
+            <a:off x="21524257" y="14128166"/>
+            <a:ext cx="6857286" cy="811558"/>
           </a:xfrm>
           <a:prstGeom prst="rect">
             <a:avLst/>
@@ -2988,7 +2640,7 @@
           <a:bodyPr vert="horz" lIns="91440" tIns="45720" rIns="91440" bIns="45720" rtlCol="0" anchor="ctr"/>
           <a:lstStyle>
             <a:lvl1pPr algn="r">
-              <a:defRPr sz="1200">
+              <a:defRPr sz="2667">
                 <a:solidFill>
                   <a:schemeClr val="tx1">
                     <a:tint val="82000"/>
@@ -3009,27 +2661,27 @@
     </p:spTree>
     <p:extLst>
       <p:ext uri="{BB962C8B-B14F-4D97-AF65-F5344CB8AC3E}">
-        <p14:creationId xmlns:p14="http://schemas.microsoft.com/office/powerpoint/2010/main" val="3113258004"/>
+        <p14:creationId xmlns:p14="http://schemas.microsoft.com/office/powerpoint/2010/main" val="2130470048"/>
       </p:ext>
     </p:extLst>
   </p:cSld>
   <p:clrMap bg1="lt1" tx1="dk1" bg2="lt2" tx2="dk2" accent1="accent1" accent2="accent2" accent3="accent3" accent4="accent4" accent5="accent5" accent6="accent6" hlink="hlink" folHlink="folHlink"/>
   <p:sldLayoutIdLst>
-    <p:sldLayoutId id="2147483649" r:id="rId1"/>
-    <p:sldLayoutId id="2147483650" r:id="rId2"/>
-    <p:sldLayoutId id="2147483651" r:id="rId3"/>
-    <p:sldLayoutId id="2147483652" r:id="rId4"/>
-    <p:sldLayoutId id="2147483653" r:id="rId5"/>
-    <p:sldLayoutId id="2147483654" r:id="rId6"/>
-    <p:sldLayoutId id="2147483655" r:id="rId7"/>
-    <p:sldLayoutId id="2147483656" r:id="rId8"/>
-    <p:sldLayoutId id="2147483657" r:id="rId9"/>
-    <p:sldLayoutId id="2147483658" r:id="rId10"/>
-    <p:sldLayoutId id="2147483659" r:id="rId11"/>
+    <p:sldLayoutId id="2147483661" r:id="rId1"/>
+    <p:sldLayoutId id="2147483662" r:id="rId2"/>
+    <p:sldLayoutId id="2147483663" r:id="rId3"/>
+    <p:sldLayoutId id="2147483664" r:id="rId4"/>
+    <p:sldLayoutId id="2147483665" r:id="rId5"/>
+    <p:sldLayoutId id="2147483666" r:id="rId6"/>
+    <p:sldLayoutId id="2147483667" r:id="rId7"/>
+    <p:sldLayoutId id="2147483668" r:id="rId8"/>
+    <p:sldLayoutId id="2147483669" r:id="rId9"/>
+    <p:sldLayoutId id="2147483670" r:id="rId10"/>
+    <p:sldLayoutId id="2147483671" r:id="rId11"/>
   </p:sldLayoutIdLst>
   <p:txStyles>
     <p:titleStyle>
-      <a:lvl1pPr algn="l" defTabSz="914400" rtl="0" eaLnBrk="1" latinLnBrk="0" hangingPunct="1">
+      <a:lvl1pPr algn="l" defTabSz="2032437" rtl="0" eaLnBrk="1" latinLnBrk="0" hangingPunct="1">
         <a:lnSpc>
           <a:spcPct val="90000"/>
         </a:lnSpc>
@@ -3037,7 +2689,7 @@
           <a:spcPct val="0"/>
         </a:spcBef>
         <a:buNone/>
-        <a:defRPr sz="4400" kern="1200">
+        <a:defRPr sz="9780" kern="1200">
           <a:solidFill>
             <a:schemeClr val="tx1"/>
           </a:solidFill>
@@ -3048,16 +2700,16 @@
       </a:lvl1pPr>
     </p:titleStyle>
     <p:bodyStyle>
-      <a:lvl1pPr marL="228600" indent="-228600" algn="l" defTabSz="914400" rtl="0" eaLnBrk="1" latinLnBrk="0" hangingPunct="1">
+      <a:lvl1pPr marL="508109" indent="-508109" algn="l" defTabSz="2032437" rtl="0" eaLnBrk="1" latinLnBrk="0" hangingPunct="1">
         <a:lnSpc>
           <a:spcPct val="90000"/>
         </a:lnSpc>
         <a:spcBef>
-          <a:spcPts val="1000"/>
+          <a:spcPts val="2223"/>
         </a:spcBef>
         <a:buFont typeface="Arial" panose="020B0604020202020204" pitchFamily="34" charset="0"/>
         <a:buChar char="•"/>
-        <a:defRPr sz="2800" kern="1200">
+        <a:defRPr sz="6224" kern="1200">
           <a:solidFill>
             <a:schemeClr val="tx1"/>
           </a:solidFill>
@@ -3066,16 +2718,16 @@
           <a:cs typeface="+mn-cs"/>
         </a:defRPr>
       </a:lvl1pPr>
-      <a:lvl2pPr marL="685800" indent="-228600" algn="l" defTabSz="914400" rtl="0" eaLnBrk="1" latinLnBrk="0" hangingPunct="1">
+      <a:lvl2pPr marL="1524328" indent="-508109" algn="l" defTabSz="2032437" rtl="0" eaLnBrk="1" latinLnBrk="0" hangingPunct="1">
         <a:lnSpc>
           <a:spcPct val="90000"/>
         </a:lnSpc>
         <a:spcBef>
-          <a:spcPts val="500"/>
+          <a:spcPts val="1111"/>
         </a:spcBef>
         <a:buFont typeface="Arial" panose="020B0604020202020204" pitchFamily="34" charset="0"/>
         <a:buChar char="•"/>
-        <a:defRPr sz="2400" kern="1200">
+        <a:defRPr sz="5334" kern="1200">
           <a:solidFill>
             <a:schemeClr val="tx1"/>
           </a:solidFill>
@@ -3084,16 +2736,16 @@
           <a:cs typeface="+mn-cs"/>
         </a:defRPr>
       </a:lvl2pPr>
-      <a:lvl3pPr marL="1143000" indent="-228600" algn="l" defTabSz="914400" rtl="0" eaLnBrk="1" latinLnBrk="0" hangingPunct="1">
+      <a:lvl3pPr marL="2540546" indent="-508109" algn="l" defTabSz="2032437" rtl="0" eaLnBrk="1" latinLnBrk="0" hangingPunct="1">
         <a:lnSpc>
           <a:spcPct val="90000"/>
         </a:lnSpc>
         <a:spcBef>
-          <a:spcPts val="500"/>
+          <a:spcPts val="1111"/>
         </a:spcBef>
         <a:buFont typeface="Arial" panose="020B0604020202020204" pitchFamily="34" charset="0"/>
         <a:buChar char="•"/>
-        <a:defRPr sz="2000" kern="1200">
+        <a:defRPr sz="4445" kern="1200">
           <a:solidFill>
             <a:schemeClr val="tx1"/>
           </a:solidFill>
@@ -3102,16 +2754,16 @@
           <a:cs typeface="+mn-cs"/>
         </a:defRPr>
       </a:lvl3pPr>
-      <a:lvl4pPr marL="1600200" indent="-228600" algn="l" defTabSz="914400" rtl="0" eaLnBrk="1" latinLnBrk="0" hangingPunct="1">
+      <a:lvl4pPr marL="3556765" indent="-508109" algn="l" defTabSz="2032437" rtl="0" eaLnBrk="1" latinLnBrk="0" hangingPunct="1">
         <a:lnSpc>
           <a:spcPct val="90000"/>
         </a:lnSpc>
         <a:spcBef>
-          <a:spcPts val="500"/>
+          <a:spcPts val="1111"/>
         </a:spcBef>
         <a:buFont typeface="Arial" panose="020B0604020202020204" pitchFamily="34" charset="0"/>
         <a:buChar char="•"/>
-        <a:defRPr sz="1800" kern="1200">
+        <a:defRPr sz="4001" kern="1200">
           <a:solidFill>
             <a:schemeClr val="tx1"/>
           </a:solidFill>
@@ -3120,16 +2772,16 @@
           <a:cs typeface="+mn-cs"/>
         </a:defRPr>
       </a:lvl4pPr>
-      <a:lvl5pPr marL="2057400" indent="-228600" algn="l" defTabSz="914400" rtl="0" eaLnBrk="1" latinLnBrk="0" hangingPunct="1">
+      <a:lvl5pPr marL="4572983" indent="-508109" algn="l" defTabSz="2032437" rtl="0" eaLnBrk="1" latinLnBrk="0" hangingPunct="1">
         <a:lnSpc>
           <a:spcPct val="90000"/>
         </a:lnSpc>
         <a:spcBef>
-          <a:spcPts val="500"/>
+          <a:spcPts val="1111"/>
         </a:spcBef>
         <a:buFont typeface="Arial" panose="020B0604020202020204" pitchFamily="34" charset="0"/>
         <a:buChar char="•"/>
-        <a:defRPr sz="1800" kern="1200">
+        <a:defRPr sz="4001" kern="1200">
           <a:solidFill>
             <a:schemeClr val="tx1"/>
           </a:solidFill>
@@ -3138,16 +2790,16 @@
           <a:cs typeface="+mn-cs"/>
         </a:defRPr>
       </a:lvl5pPr>
-      <a:lvl6pPr marL="2514600" indent="-228600" algn="l" defTabSz="914400" rtl="0" eaLnBrk="1" latinLnBrk="0" hangingPunct="1">
+      <a:lvl6pPr marL="5589201" indent="-508109" algn="l" defTabSz="2032437" rtl="0" eaLnBrk="1" latinLnBrk="0" hangingPunct="1">
         <a:lnSpc>
           <a:spcPct val="90000"/>
         </a:lnSpc>
         <a:spcBef>
-          <a:spcPts val="500"/>
+          <a:spcPts val="1111"/>
         </a:spcBef>
         <a:buFont typeface="Arial" panose="020B0604020202020204" pitchFamily="34" charset="0"/>
         <a:buChar char="•"/>
-        <a:defRPr sz="1800" kern="1200">
+        <a:defRPr sz="4001" kern="1200">
           <a:solidFill>
             <a:schemeClr val="tx1"/>
           </a:solidFill>
@@ -3156,16 +2808,16 @@
           <a:cs typeface="+mn-cs"/>
         </a:defRPr>
       </a:lvl6pPr>
-      <a:lvl7pPr marL="2971800" indent="-228600" algn="l" defTabSz="914400" rtl="0" eaLnBrk="1" latinLnBrk="0" hangingPunct="1">
+      <a:lvl7pPr marL="6605420" indent="-508109" algn="l" defTabSz="2032437" rtl="0" eaLnBrk="1" latinLnBrk="0" hangingPunct="1">
         <a:lnSpc>
           <a:spcPct val="90000"/>
         </a:lnSpc>
         <a:spcBef>
-          <a:spcPts val="500"/>
+          <a:spcPts val="1111"/>
         </a:spcBef>
         <a:buFont typeface="Arial" panose="020B0604020202020204" pitchFamily="34" charset="0"/>
         <a:buChar char="•"/>
-        <a:defRPr sz="1800" kern="1200">
+        <a:defRPr sz="4001" kern="1200">
           <a:solidFill>
             <a:schemeClr val="tx1"/>
           </a:solidFill>
@@ -3174,16 +2826,16 @@
           <a:cs typeface="+mn-cs"/>
         </a:defRPr>
       </a:lvl7pPr>
-      <a:lvl8pPr marL="3429000" indent="-228600" algn="l" defTabSz="914400" rtl="0" eaLnBrk="1" latinLnBrk="0" hangingPunct="1">
+      <a:lvl8pPr marL="7621638" indent="-508109" algn="l" defTabSz="2032437" rtl="0" eaLnBrk="1" latinLnBrk="0" hangingPunct="1">
         <a:lnSpc>
           <a:spcPct val="90000"/>
         </a:lnSpc>
         <a:spcBef>
-          <a:spcPts val="500"/>
+          <a:spcPts val="1111"/>
         </a:spcBef>
         <a:buFont typeface="Arial" panose="020B0604020202020204" pitchFamily="34" charset="0"/>
         <a:buChar char="•"/>
-        <a:defRPr sz="1800" kern="1200">
+        <a:defRPr sz="4001" kern="1200">
           <a:solidFill>
             <a:schemeClr val="tx1"/>
           </a:solidFill>
@@ -3192,16 +2844,16 @@
           <a:cs typeface="+mn-cs"/>
         </a:defRPr>
       </a:lvl8pPr>
-      <a:lvl9pPr marL="3886200" indent="-228600" algn="l" defTabSz="914400" rtl="0" eaLnBrk="1" latinLnBrk="0" hangingPunct="1">
+      <a:lvl9pPr marL="8637857" indent="-508109" algn="l" defTabSz="2032437" rtl="0" eaLnBrk="1" latinLnBrk="0" hangingPunct="1">
         <a:lnSpc>
           <a:spcPct val="90000"/>
         </a:lnSpc>
         <a:spcBef>
-          <a:spcPts val="500"/>
+          <a:spcPts val="1111"/>
         </a:spcBef>
         <a:buFont typeface="Arial" panose="020B0604020202020204" pitchFamily="34" charset="0"/>
         <a:buChar char="•"/>
-        <a:defRPr sz="1800" kern="1200">
+        <a:defRPr sz="4001" kern="1200">
           <a:solidFill>
             <a:schemeClr val="tx1"/>
           </a:solidFill>
@@ -3215,8 +2867,8 @@
       <a:defPPr>
         <a:defRPr lang="en-US"/>
       </a:defPPr>
-      <a:lvl1pPr marL="0" algn="l" defTabSz="914400" rtl="0" eaLnBrk="1" latinLnBrk="0" hangingPunct="1">
-        <a:defRPr sz="1800" kern="1200">
+      <a:lvl1pPr marL="0" algn="l" defTabSz="2032437" rtl="0" eaLnBrk="1" latinLnBrk="0" hangingPunct="1">
+        <a:defRPr sz="4001" kern="1200">
           <a:solidFill>
             <a:schemeClr val="tx1"/>
           </a:solidFill>
@@ -3225,8 +2877,8 @@
           <a:cs typeface="+mn-cs"/>
         </a:defRPr>
       </a:lvl1pPr>
-      <a:lvl2pPr marL="457200" algn="l" defTabSz="914400" rtl="0" eaLnBrk="1" latinLnBrk="0" hangingPunct="1">
-        <a:defRPr sz="1800" kern="1200">
+      <a:lvl2pPr marL="1016218" algn="l" defTabSz="2032437" rtl="0" eaLnBrk="1" latinLnBrk="0" hangingPunct="1">
+        <a:defRPr sz="4001" kern="1200">
           <a:solidFill>
             <a:schemeClr val="tx1"/>
           </a:solidFill>
@@ -3235,8 +2887,8 @@
           <a:cs typeface="+mn-cs"/>
         </a:defRPr>
       </a:lvl2pPr>
-      <a:lvl3pPr marL="914400" algn="l" defTabSz="914400" rtl="0" eaLnBrk="1" latinLnBrk="0" hangingPunct="1">
-        <a:defRPr sz="1800" kern="1200">
+      <a:lvl3pPr marL="2032437" algn="l" defTabSz="2032437" rtl="0" eaLnBrk="1" latinLnBrk="0" hangingPunct="1">
+        <a:defRPr sz="4001" kern="1200">
           <a:solidFill>
             <a:schemeClr val="tx1"/>
           </a:solidFill>
@@ -3245,8 +2897,8 @@
           <a:cs typeface="+mn-cs"/>
         </a:defRPr>
       </a:lvl3pPr>
-      <a:lvl4pPr marL="1371600" algn="l" defTabSz="914400" rtl="0" eaLnBrk="1" latinLnBrk="0" hangingPunct="1">
-        <a:defRPr sz="1800" kern="1200">
+      <a:lvl4pPr marL="3048655" algn="l" defTabSz="2032437" rtl="0" eaLnBrk="1" latinLnBrk="0" hangingPunct="1">
+        <a:defRPr sz="4001" kern="1200">
           <a:solidFill>
             <a:schemeClr val="tx1"/>
           </a:solidFill>
@@ -3255,8 +2907,8 @@
           <a:cs typeface="+mn-cs"/>
         </a:defRPr>
       </a:lvl4pPr>
-      <a:lvl5pPr marL="1828800" algn="l" defTabSz="914400" rtl="0" eaLnBrk="1" latinLnBrk="0" hangingPunct="1">
-        <a:defRPr sz="1800" kern="1200">
+      <a:lvl5pPr marL="4064874" algn="l" defTabSz="2032437" rtl="0" eaLnBrk="1" latinLnBrk="0" hangingPunct="1">
+        <a:defRPr sz="4001" kern="1200">
           <a:solidFill>
             <a:schemeClr val="tx1"/>
           </a:solidFill>
@@ -3265,8 +2917,8 @@
           <a:cs typeface="+mn-cs"/>
         </a:defRPr>
       </a:lvl5pPr>
-      <a:lvl6pPr marL="2286000" algn="l" defTabSz="914400" rtl="0" eaLnBrk="1" latinLnBrk="0" hangingPunct="1">
-        <a:defRPr sz="1800" kern="1200">
+      <a:lvl6pPr marL="5081092" algn="l" defTabSz="2032437" rtl="0" eaLnBrk="1" latinLnBrk="0" hangingPunct="1">
+        <a:defRPr sz="4001" kern="1200">
           <a:solidFill>
             <a:schemeClr val="tx1"/>
           </a:solidFill>
@@ -3275,8 +2927,8 @@
           <a:cs typeface="+mn-cs"/>
         </a:defRPr>
       </a:lvl6pPr>
-      <a:lvl7pPr marL="2743200" algn="l" defTabSz="914400" rtl="0" eaLnBrk="1" latinLnBrk="0" hangingPunct="1">
-        <a:defRPr sz="1800" kern="1200">
+      <a:lvl7pPr marL="6097311" algn="l" defTabSz="2032437" rtl="0" eaLnBrk="1" latinLnBrk="0" hangingPunct="1">
+        <a:defRPr sz="4001" kern="1200">
           <a:solidFill>
             <a:schemeClr val="tx1"/>
           </a:solidFill>
@@ -3285,8 +2937,8 @@
           <a:cs typeface="+mn-cs"/>
         </a:defRPr>
       </a:lvl7pPr>
-      <a:lvl8pPr marL="3200400" algn="l" defTabSz="914400" rtl="0" eaLnBrk="1" latinLnBrk="0" hangingPunct="1">
-        <a:defRPr sz="1800" kern="1200">
+      <a:lvl8pPr marL="7113529" algn="l" defTabSz="2032437" rtl="0" eaLnBrk="1" latinLnBrk="0" hangingPunct="1">
+        <a:defRPr sz="4001" kern="1200">
           <a:solidFill>
             <a:schemeClr val="tx1"/>
           </a:solidFill>
@@ -3295,8 +2947,8 @@
           <a:cs typeface="+mn-cs"/>
         </a:defRPr>
       </a:lvl8pPr>
-      <a:lvl9pPr marL="3657600" algn="l" defTabSz="914400" rtl="0" eaLnBrk="1" latinLnBrk="0" hangingPunct="1">
-        <a:defRPr sz="1800" kern="1200">
+      <a:lvl9pPr marL="8129748" algn="l" defTabSz="2032437" rtl="0" eaLnBrk="1" latinLnBrk="0" hangingPunct="1">
+        <a:defRPr sz="4001" kern="1200">
           <a:solidFill>
             <a:schemeClr val="tx1"/>
           </a:solidFill>
@@ -3349,8 +3001,8 @@
         </p:blipFill>
         <p:spPr>
           <a:xfrm>
-            <a:off x="210207" y="-4379"/>
-            <a:ext cx="11764078" cy="6862379"/>
+            <a:off x="2156147" y="-9732"/>
+            <a:ext cx="26147842" cy="15252908"/>
           </a:xfrm>
           <a:prstGeom prst="rect">
             <a:avLst/>
@@ -3371,8 +3023,8 @@
         </p:nvSpPr>
         <p:spPr>
           <a:xfrm rot="1508250">
-            <a:off x="1085194" y="2101404"/>
-            <a:ext cx="10585246" cy="2123658"/>
+            <a:off x="4100968" y="4727163"/>
+            <a:ext cx="23527669" cy="4607415"/>
           </a:xfrm>
           <a:prstGeom prst="rect">
             <a:avLst/>
@@ -3390,24 +3042,24 @@
           <a:p>
             <a:pPr algn="ctr"/>
             <a:r>
-              <a:rPr lang="en-US" sz="6600" dirty="0" err="1">
+              <a:rPr lang="en-US" sz="14670" dirty="0" err="1">
                 <a:solidFill>
                   <a:schemeClr val="tx1">
                     <a:lumMod val="65000"/>
                     <a:lumOff val="35000"/>
-                    <a:alpha val="15000"/>
+                    <a:alpha val="10000"/>
                   </a:schemeClr>
                 </a:solidFill>
               </a:rPr>
               <a:t>SuperNEMO</a:t>
             </a:r>
             <a:r>
-              <a:rPr lang="en-US" sz="6600" dirty="0">
+              <a:rPr lang="en-US" sz="14670" dirty="0">
                 <a:solidFill>
                   <a:schemeClr val="tx1">
                     <a:lumMod val="65000"/>
                     <a:lumOff val="35000"/>
-                    <a:alpha val="15000"/>
+                    <a:alpha val="10000"/>
                   </a:schemeClr>
                 </a:solidFill>
               </a:rPr>
@@ -3417,12 +3069,12 @@
           <a:p>
             <a:pPr algn="ctr"/>
             <a:r>
-              <a:rPr lang="en-US" sz="6600" dirty="0">
+              <a:rPr lang="en-US" sz="14670" dirty="0">
                 <a:solidFill>
                   <a:schemeClr val="tx1">
                     <a:lumMod val="65000"/>
                     <a:lumOff val="35000"/>
-                    <a:alpha val="15000"/>
+                    <a:alpha val="10000"/>
                   </a:schemeClr>
                 </a:solidFill>
               </a:rPr>
@@ -3477,14 +3129,13 @@
         </p:nvPicPr>
         <p:blipFill>
           <a:blip r:embed="rId2"/>
-          <a:stretch>
-            <a:fillRect/>
-          </a:stretch>
+          <a:srcRect/>
+          <a:stretch/>
         </p:blipFill>
         <p:spPr>
           <a:xfrm>
-            <a:off x="1196235" y="-835"/>
-            <a:ext cx="9814143" cy="6869899"/>
+            <a:off x="754316" y="77787"/>
+            <a:ext cx="28968192" cy="15087600"/>
           </a:xfrm>
           <a:prstGeom prst="rect">
             <a:avLst/>
@@ -3505,8 +3156,8 @@
         </p:nvSpPr>
         <p:spPr>
           <a:xfrm rot="1508250">
-            <a:off x="1085194" y="2101404"/>
-            <a:ext cx="10585246" cy="2123658"/>
+            <a:off x="807092" y="4615739"/>
+            <a:ext cx="29223565" cy="4607415"/>
           </a:xfrm>
           <a:prstGeom prst="rect">
             <a:avLst/>
@@ -3524,24 +3175,24 @@
           <a:p>
             <a:pPr algn="ctr"/>
             <a:r>
-              <a:rPr lang="en-US" sz="6600" dirty="0" err="1">
+              <a:rPr lang="en-US" sz="14670" dirty="0" err="1">
                 <a:solidFill>
                   <a:schemeClr val="tx1">
                     <a:lumMod val="65000"/>
                     <a:lumOff val="35000"/>
-                    <a:alpha val="15000"/>
+                    <a:alpha val="10000"/>
                   </a:schemeClr>
                 </a:solidFill>
               </a:rPr>
               <a:t>SuperNEMO</a:t>
             </a:r>
             <a:r>
-              <a:rPr lang="en-US" sz="6600" dirty="0">
+              <a:rPr lang="en-US" sz="14670" dirty="0">
                 <a:solidFill>
                   <a:schemeClr val="tx1">
                     <a:lumMod val="65000"/>
                     <a:lumOff val="35000"/>
-                    <a:alpha val="15000"/>
+                    <a:alpha val="10000"/>
                   </a:schemeClr>
                 </a:solidFill>
               </a:rPr>
@@ -3551,12 +3202,12 @@
           <a:p>
             <a:pPr algn="ctr"/>
             <a:r>
-              <a:rPr lang="en-US" sz="6600" dirty="0">
+              <a:rPr lang="en-US" sz="14670" dirty="0">
                 <a:solidFill>
                   <a:schemeClr val="tx1">
                     <a:lumMod val="65000"/>
                     <a:lumOff val="35000"/>
-                    <a:alpha val="15000"/>
+                    <a:alpha val="10000"/>
                   </a:schemeClr>
                 </a:solidFill>
               </a:rPr>
@@ -3579,6 +3230,145 @@
 </file>
 
 <file path=ppt/slides/slide3.xml><?xml version="1.0" encoding="utf-8"?>
+<p:sld xmlns:a="http://schemas.openxmlformats.org/drawingml/2006/main" xmlns:r="http://schemas.openxmlformats.org/officeDocument/2006/relationships" xmlns:p="http://schemas.openxmlformats.org/presentationml/2006/main">
+  <p:cSld>
+    <p:spTree>
+      <p:nvGrpSpPr>
+        <p:cNvPr id="1" name="">
+          <a:extLst>
+            <a:ext uri="{FF2B5EF4-FFF2-40B4-BE49-F238E27FC236}">
+              <a16:creationId xmlns:a16="http://schemas.microsoft.com/office/drawing/2014/main" id="{D4C5F829-B3C1-0296-5AF8-68BB4F880284}"/>
+            </a:ext>
+          </a:extLst>
+        </p:cNvPr>
+        <p:cNvGrpSpPr/>
+        <p:nvPr/>
+      </p:nvGrpSpPr>
+      <p:grpSpPr>
+        <a:xfrm>
+          <a:off x="0" y="0"/>
+          <a:ext cx="0" cy="0"/>
+          <a:chOff x="0" y="0"/>
+          <a:chExt cx="0" cy="0"/>
+        </a:xfrm>
+      </p:grpSpPr>
+      <p:pic>
+        <p:nvPicPr>
+          <p:cNvPr id="4" name="Picture 3">
+            <a:extLst>
+              <a:ext uri="{FF2B5EF4-FFF2-40B4-BE49-F238E27FC236}">
+                <a16:creationId xmlns:a16="http://schemas.microsoft.com/office/drawing/2014/main" id="{11252458-AC4E-066C-3493-8151958EE88B}"/>
+              </a:ext>
+            </a:extLst>
+          </p:cNvPr>
+          <p:cNvPicPr>
+            <a:picLocks noChangeAspect="1"/>
+          </p:cNvPicPr>
+          <p:nvPr/>
+        </p:nvPicPr>
+        <p:blipFill>
+          <a:blip r:embed="rId2"/>
+          <a:srcRect/>
+          <a:stretch/>
+        </p:blipFill>
+        <p:spPr>
+          <a:xfrm>
+            <a:off x="754316" y="77787"/>
+            <a:ext cx="28968191" cy="15087600"/>
+          </a:xfrm>
+          <a:prstGeom prst="rect">
+            <a:avLst/>
+          </a:prstGeom>
+        </p:spPr>
+      </p:pic>
+      <p:sp>
+        <p:nvSpPr>
+          <p:cNvPr id="3" name="TextBox 2">
+            <a:extLst>
+              <a:ext uri="{FF2B5EF4-FFF2-40B4-BE49-F238E27FC236}">
+                <a16:creationId xmlns:a16="http://schemas.microsoft.com/office/drawing/2014/main" id="{58DC0D80-3CE6-94DA-08CC-E78CAB5FB578}"/>
+              </a:ext>
+            </a:extLst>
+          </p:cNvPr>
+          <p:cNvSpPr txBox="1"/>
+          <p:nvPr/>
+        </p:nvSpPr>
+        <p:spPr>
+          <a:xfrm rot="1508250">
+            <a:off x="807092" y="4615739"/>
+            <a:ext cx="29223565" cy="4607415"/>
+          </a:xfrm>
+          <a:prstGeom prst="rect">
+            <a:avLst/>
+          </a:prstGeom>
+          <a:noFill/>
+          <a:ln>
+            <a:noFill/>
+          </a:ln>
+        </p:spPr>
+        <p:txBody>
+          <a:bodyPr wrap="square" rtlCol="0">
+            <a:spAutoFit/>
+          </a:bodyPr>
+          <a:lstStyle/>
+          <a:p>
+            <a:pPr algn="ctr"/>
+            <a:r>
+              <a:rPr lang="en-US" sz="14670" dirty="0" err="1">
+                <a:solidFill>
+                  <a:schemeClr val="tx1">
+                    <a:lumMod val="65000"/>
+                    <a:lumOff val="35000"/>
+                    <a:alpha val="10000"/>
+                  </a:schemeClr>
+                </a:solidFill>
+              </a:rPr>
+              <a:t>SuperNEMO</a:t>
+            </a:r>
+            <a:r>
+              <a:rPr lang="en-US" sz="14670" dirty="0">
+                <a:solidFill>
+                  <a:schemeClr val="tx1">
+                    <a:lumMod val="65000"/>
+                    <a:lumOff val="35000"/>
+                    <a:alpha val="10000"/>
+                  </a:schemeClr>
+                </a:solidFill>
+              </a:rPr>
+              <a:t> preliminary</a:t>
+            </a:r>
+          </a:p>
+          <a:p>
+            <a:pPr algn="ctr"/>
+            <a:r>
+              <a:rPr lang="en-US" sz="14670" dirty="0">
+                <a:solidFill>
+                  <a:schemeClr val="tx1">
+                    <a:lumMod val="65000"/>
+                    <a:lumOff val="35000"/>
+                    <a:alpha val="10000"/>
+                  </a:schemeClr>
+                </a:solidFill>
+              </a:rPr>
+              <a:t>Thesis work</a:t>
+            </a:r>
+          </a:p>
+        </p:txBody>
+      </p:sp>
+    </p:spTree>
+    <p:extLst>
+      <p:ext uri="{BB962C8B-B14F-4D97-AF65-F5344CB8AC3E}">
+        <p14:creationId xmlns:p14="http://schemas.microsoft.com/office/powerpoint/2010/main" val="1711964135"/>
+      </p:ext>
+    </p:extLst>
+  </p:cSld>
+  <p:clrMapOvr>
+    <a:masterClrMapping/>
+  </p:clrMapOvr>
+</p:sld>
+</file>
+
+<file path=ppt/slides/slide4.xml><?xml version="1.0" encoding="utf-8"?>
 <p:sld xmlns:a="http://schemas.openxmlformats.org/drawingml/2006/main" xmlns:r="http://schemas.openxmlformats.org/officeDocument/2006/relationships" xmlns:p="http://schemas.openxmlformats.org/presentationml/2006/main">
   <p:cSld>
     <p:spTree>
@@ -3622,8 +3412,8 @@
         </p:blipFill>
         <p:spPr>
           <a:xfrm>
-            <a:off x="1196236" y="-835"/>
-            <a:ext cx="9814141" cy="6869899"/>
+            <a:off x="754317" y="77787"/>
+            <a:ext cx="28968191" cy="15087600"/>
           </a:xfrm>
           <a:prstGeom prst="rect">
             <a:avLst/>
@@ -3644,8 +3434,8 @@
         </p:nvSpPr>
         <p:spPr>
           <a:xfrm rot="1508250">
-            <a:off x="1085194" y="2101404"/>
-            <a:ext cx="10585246" cy="2123658"/>
+            <a:off x="4100968" y="4727163"/>
+            <a:ext cx="23527669" cy="4607415"/>
           </a:xfrm>
           <a:prstGeom prst="rect">
             <a:avLst/>
@@ -3663,7 +3453,7 @@
           <a:p>
             <a:pPr algn="ctr"/>
             <a:r>
-              <a:rPr lang="en-US" sz="6600" dirty="0" err="1">
+              <a:rPr lang="en-US" sz="14670" dirty="0" err="1">
                 <a:solidFill>
                   <a:schemeClr val="tx1">
                     <a:lumMod val="65000"/>
@@ -3675,7 +3465,7 @@
               <a:t>SuperNEMO</a:t>
             </a:r>
             <a:r>
-              <a:rPr lang="en-US" sz="6600" dirty="0">
+              <a:rPr lang="en-US" sz="14670" dirty="0">
                 <a:solidFill>
                   <a:schemeClr val="tx1">
                     <a:lumMod val="65000"/>
@@ -3684,13 +3474,25 @@
                   </a:schemeClr>
                 </a:solidFill>
               </a:rPr>
-              <a:t> preliminary</a:t>
+              <a:t> </a:t>
+            </a:r>
+            <a:r>
+              <a:rPr lang="en-US" sz="14670" dirty="0">
+                <a:solidFill>
+                  <a:schemeClr val="tx1">
+                    <a:lumMod val="65000"/>
+                    <a:lumOff val="35000"/>
+                    <a:alpha val="10000"/>
+                  </a:schemeClr>
+                </a:solidFill>
+              </a:rPr>
+              <a:t>preliminary</a:t>
             </a:r>
           </a:p>
           <a:p>
             <a:pPr algn="ctr"/>
             <a:r>
-              <a:rPr lang="en-US" sz="6600" dirty="0">
+              <a:rPr lang="en-US" sz="14670" dirty="0">
                 <a:solidFill>
                   <a:schemeClr val="tx1">
                     <a:lumMod val="65000"/>
@@ -3708,145 +3510,6 @@
     <p:extLst>
       <p:ext uri="{BB962C8B-B14F-4D97-AF65-F5344CB8AC3E}">
         <p14:creationId xmlns:p14="http://schemas.microsoft.com/office/powerpoint/2010/main" val="1720621210"/>
-      </p:ext>
-    </p:extLst>
-  </p:cSld>
-  <p:clrMapOvr>
-    <a:masterClrMapping/>
-  </p:clrMapOvr>
-</p:sld>
-</file>
-
-<file path=ppt/slides/slide4.xml><?xml version="1.0" encoding="utf-8"?>
-<p:sld xmlns:a="http://schemas.openxmlformats.org/drawingml/2006/main" xmlns:r="http://schemas.openxmlformats.org/officeDocument/2006/relationships" xmlns:p="http://schemas.openxmlformats.org/presentationml/2006/main">
-  <p:cSld>
-    <p:spTree>
-      <p:nvGrpSpPr>
-        <p:cNvPr id="1" name="">
-          <a:extLst>
-            <a:ext uri="{FF2B5EF4-FFF2-40B4-BE49-F238E27FC236}">
-              <a16:creationId xmlns:a16="http://schemas.microsoft.com/office/drawing/2014/main" id="{D4C5F829-B3C1-0296-5AF8-68BB4F880284}"/>
-            </a:ext>
-          </a:extLst>
-        </p:cNvPr>
-        <p:cNvGrpSpPr/>
-        <p:nvPr/>
-      </p:nvGrpSpPr>
-      <p:grpSpPr>
-        <a:xfrm>
-          <a:off x="0" y="0"/>
-          <a:ext cx="0" cy="0"/>
-          <a:chOff x="0" y="0"/>
-          <a:chExt cx="0" cy="0"/>
-        </a:xfrm>
-      </p:grpSpPr>
-      <p:pic>
-        <p:nvPicPr>
-          <p:cNvPr id="4" name="Picture 3">
-            <a:extLst>
-              <a:ext uri="{FF2B5EF4-FFF2-40B4-BE49-F238E27FC236}">
-                <a16:creationId xmlns:a16="http://schemas.microsoft.com/office/drawing/2014/main" id="{11252458-AC4E-066C-3493-8151958EE88B}"/>
-              </a:ext>
-            </a:extLst>
-          </p:cNvPr>
-          <p:cNvPicPr>
-            <a:picLocks noChangeAspect="1"/>
-          </p:cNvPicPr>
-          <p:nvPr/>
-        </p:nvPicPr>
-        <p:blipFill>
-          <a:blip r:embed="rId2"/>
-          <a:srcRect/>
-          <a:stretch/>
-        </p:blipFill>
-        <p:spPr>
-          <a:xfrm>
-            <a:off x="1196236" y="-835"/>
-            <a:ext cx="9814141" cy="6869898"/>
-          </a:xfrm>
-          <a:prstGeom prst="rect">
-            <a:avLst/>
-          </a:prstGeom>
-        </p:spPr>
-      </p:pic>
-      <p:sp>
-        <p:nvSpPr>
-          <p:cNvPr id="2" name="TextBox 1">
-            <a:extLst>
-              <a:ext uri="{FF2B5EF4-FFF2-40B4-BE49-F238E27FC236}">
-                <a16:creationId xmlns:a16="http://schemas.microsoft.com/office/drawing/2014/main" id="{94509659-F248-FD73-8756-2CE7A45C55C7}"/>
-              </a:ext>
-            </a:extLst>
-          </p:cNvPr>
-          <p:cNvSpPr txBox="1"/>
-          <p:nvPr/>
-        </p:nvSpPr>
-        <p:spPr>
-          <a:xfrm rot="1508250">
-            <a:off x="1085194" y="2101404"/>
-            <a:ext cx="10585246" cy="2123658"/>
-          </a:xfrm>
-          <a:prstGeom prst="rect">
-            <a:avLst/>
-          </a:prstGeom>
-          <a:noFill/>
-          <a:ln>
-            <a:noFill/>
-          </a:ln>
-        </p:spPr>
-        <p:txBody>
-          <a:bodyPr wrap="square" rtlCol="0">
-            <a:spAutoFit/>
-          </a:bodyPr>
-          <a:lstStyle/>
-          <a:p>
-            <a:pPr algn="ctr"/>
-            <a:r>
-              <a:rPr lang="en-US" sz="6600" dirty="0" err="1">
-                <a:solidFill>
-                  <a:schemeClr val="tx1">
-                    <a:lumMod val="65000"/>
-                    <a:lumOff val="35000"/>
-                    <a:alpha val="15000"/>
-                  </a:schemeClr>
-                </a:solidFill>
-              </a:rPr>
-              <a:t>SuperNEMO</a:t>
-            </a:r>
-            <a:r>
-              <a:rPr lang="en-US" sz="6600" dirty="0">
-                <a:solidFill>
-                  <a:schemeClr val="tx1">
-                    <a:lumMod val="65000"/>
-                    <a:lumOff val="35000"/>
-                    <a:alpha val="15000"/>
-                  </a:schemeClr>
-                </a:solidFill>
-              </a:rPr>
-              <a:t> preliminary</a:t>
-            </a:r>
-          </a:p>
-          <a:p>
-            <a:pPr algn="ctr"/>
-            <a:r>
-              <a:rPr lang="en-US" sz="6600" dirty="0">
-                <a:solidFill>
-                  <a:schemeClr val="tx1">
-                    <a:lumMod val="65000"/>
-                    <a:lumOff val="35000"/>
-                    <a:alpha val="15000"/>
-                  </a:schemeClr>
-                </a:solidFill>
-              </a:rPr>
-              <a:t>Thesis work</a:t>
-            </a:r>
-          </a:p>
-        </p:txBody>
-      </p:sp>
-    </p:spTree>
-    <p:extLst>
-      <p:ext uri="{BB962C8B-B14F-4D97-AF65-F5344CB8AC3E}">
-        <p14:creationId xmlns:p14="http://schemas.microsoft.com/office/powerpoint/2010/main" val="1711964135"/>
       </p:ext>
     </p:extLst>
   </p:cSld>
@@ -3900,8 +3563,8 @@
         </p:blipFill>
         <p:spPr>
           <a:xfrm>
-            <a:off x="1196236" y="-835"/>
-            <a:ext cx="9814140" cy="6869898"/>
+            <a:off x="754316" y="77787"/>
+            <a:ext cx="28968193" cy="15087600"/>
           </a:xfrm>
           <a:prstGeom prst="rect">
             <a:avLst/>
@@ -3922,8 +3585,8 @@
         </p:nvSpPr>
         <p:spPr>
           <a:xfrm rot="1508250">
-            <a:off x="1085194" y="2101404"/>
-            <a:ext cx="10585246" cy="2123658"/>
+            <a:off x="4100968" y="4727163"/>
+            <a:ext cx="23527669" cy="4607415"/>
           </a:xfrm>
           <a:prstGeom prst="rect">
             <a:avLst/>
@@ -3941,19 +3604,19 @@
           <a:p>
             <a:pPr algn="ctr"/>
             <a:r>
-              <a:rPr lang="en-US" sz="6600" dirty="0" err="1">
+              <a:rPr lang="en-US" sz="14670" dirty="0" err="1">
                 <a:solidFill>
                   <a:schemeClr val="tx1">
                     <a:lumMod val="65000"/>
                     <a:lumOff val="35000"/>
-                    <a:alpha val="15000"/>
+                    <a:alpha val="10000"/>
                   </a:schemeClr>
                 </a:solidFill>
               </a:rPr>
               <a:t>SuperNEMO</a:t>
             </a:r>
             <a:r>
-              <a:rPr lang="en-US" sz="6600" dirty="0">
+              <a:rPr lang="en-US" sz="14670" dirty="0">
                 <a:solidFill>
                   <a:schemeClr val="tx1">
                     <a:lumMod val="65000"/>
@@ -3968,7 +3631,7 @@
           <a:p>
             <a:pPr algn="ctr"/>
             <a:r>
-              <a:rPr lang="en-US" sz="6600" dirty="0">
+              <a:rPr lang="en-US" sz="14670" dirty="0">
                 <a:solidFill>
                   <a:schemeClr val="tx1">
                     <a:lumMod val="65000"/>
@@ -4039,8 +3702,8 @@
         </p:blipFill>
         <p:spPr>
           <a:xfrm>
-            <a:off x="1196236" y="-835"/>
-            <a:ext cx="9814140" cy="6869898"/>
+            <a:off x="754316" y="77787"/>
+            <a:ext cx="28968193" cy="15087600"/>
           </a:xfrm>
           <a:prstGeom prst="rect">
             <a:avLst/>
@@ -4061,8 +3724,8 @@
         </p:nvSpPr>
         <p:spPr>
           <a:xfrm rot="1508250">
-            <a:off x="1085194" y="2101404"/>
-            <a:ext cx="10585246" cy="2123658"/>
+            <a:off x="4100968" y="4727163"/>
+            <a:ext cx="23527669" cy="4607415"/>
           </a:xfrm>
           <a:prstGeom prst="rect">
             <a:avLst/>
@@ -4080,7 +3743,7 @@
           <a:p>
             <a:pPr algn="ctr"/>
             <a:r>
-              <a:rPr lang="en-US" sz="6600" dirty="0" err="1">
+              <a:rPr lang="en-US" sz="14670" dirty="0" err="1">
                 <a:solidFill>
                   <a:schemeClr val="tx1">
                     <a:lumMod val="65000"/>
@@ -4092,7 +3755,7 @@
               <a:t>SuperNEMO</a:t>
             </a:r>
             <a:r>
-              <a:rPr lang="en-US" sz="6600" dirty="0">
+              <a:rPr lang="en-US" sz="14670" dirty="0">
                 <a:solidFill>
                   <a:schemeClr val="tx1">
                     <a:lumMod val="65000"/>
@@ -4101,13 +3764,25 @@
                   </a:schemeClr>
                 </a:solidFill>
               </a:rPr>
-              <a:t> preliminary</a:t>
+              <a:t> </a:t>
+            </a:r>
+            <a:r>
+              <a:rPr lang="en-US" sz="14670" dirty="0">
+                <a:solidFill>
+                  <a:schemeClr val="tx1">
+                    <a:lumMod val="65000"/>
+                    <a:lumOff val="35000"/>
+                    <a:alpha val="10000"/>
+                  </a:schemeClr>
+                </a:solidFill>
+              </a:rPr>
+              <a:t>preliminary</a:t>
             </a:r>
           </a:p>
           <a:p>
             <a:pPr algn="ctr"/>
             <a:r>
-              <a:rPr lang="en-US" sz="6600" dirty="0">
+              <a:rPr lang="en-US" sz="14670" dirty="0">
                 <a:solidFill>
                   <a:schemeClr val="tx1">
                     <a:lumMod val="65000"/>
@@ -4178,8 +3853,8 @@
         </p:blipFill>
         <p:spPr>
           <a:xfrm>
-            <a:off x="1196236" y="-835"/>
-            <a:ext cx="9814140" cy="6869898"/>
+            <a:off x="754316" y="77787"/>
+            <a:ext cx="28968193" cy="15087600"/>
           </a:xfrm>
           <a:prstGeom prst="rect">
             <a:avLst/>
@@ -4200,8 +3875,8 @@
         </p:nvSpPr>
         <p:spPr>
           <a:xfrm rot="1508250">
-            <a:off x="1085194" y="2101404"/>
-            <a:ext cx="10585246" cy="2123658"/>
+            <a:off x="4100968" y="4727163"/>
+            <a:ext cx="23527669" cy="4607415"/>
           </a:xfrm>
           <a:prstGeom prst="rect">
             <a:avLst/>
@@ -4219,19 +3894,19 @@
           <a:p>
             <a:pPr algn="ctr"/>
             <a:r>
-              <a:rPr lang="en-US" sz="6600" dirty="0" err="1">
+              <a:rPr lang="en-US" sz="14670" dirty="0" err="1">
                 <a:solidFill>
                   <a:schemeClr val="tx1">
                     <a:lumMod val="65000"/>
                     <a:lumOff val="35000"/>
-                    <a:alpha val="15000"/>
+                    <a:alpha val="10000"/>
                   </a:schemeClr>
                 </a:solidFill>
               </a:rPr>
               <a:t>SuperNEMO</a:t>
             </a:r>
             <a:r>
-              <a:rPr lang="en-US" sz="6600" dirty="0">
+              <a:rPr lang="en-US" sz="14670" dirty="0">
                 <a:solidFill>
                   <a:schemeClr val="tx1">
                     <a:lumMod val="65000"/>
@@ -4246,7 +3921,7 @@
           <a:p>
             <a:pPr algn="ctr"/>
             <a:r>
-              <a:rPr lang="en-US" sz="6600" dirty="0">
+              <a:rPr lang="en-US" sz="14670" dirty="0">
                 <a:solidFill>
                   <a:schemeClr val="tx1">
                     <a:lumMod val="65000"/>
@@ -4276,7 +3951,7 @@
 <file path=ppt/theme/theme1.xml><?xml version="1.0" encoding="utf-8"?>
 <a:theme xmlns:a="http://schemas.openxmlformats.org/drawingml/2006/main" name="Office Theme">
   <a:themeElements>
-    <a:clrScheme name="Office">
+    <a:clrScheme name="Office Theme">
       <a:dk1>
         <a:sysClr val="windowText" lastClr="000000"/>
       </a:dk1>
@@ -4314,7 +3989,7 @@
         <a:srgbClr val="96607D"/>
       </a:folHlink>
     </a:clrScheme>
-    <a:fontScheme name="Office">
+    <a:fontScheme name="Office Theme">
       <a:majorFont>
         <a:latin typeface="Aptos Display" panose="02110004020202020204"/>
         <a:ea typeface=""/>
@@ -4420,7 +4095,7 @@
         <a:font script="Tfng" typeface="Ebrima"/>
       </a:minorFont>
     </a:fontScheme>
-    <a:fmtScheme name="Office">
+    <a:fmtScheme name="Office Theme">
       <a:fillStyleLst>
         <a:solidFill>
           <a:schemeClr val="phClr"/>

</xml_diff>